<commit_message>
Sync pending work: webinar docs, prospecting pack updates, RAG fix
Bundles accumulated pending changes across sessions: Support IT / PII
Guard webinar guides (152-156), prospecting pack updates (SIR/SMB),
AHK_CI pack removal, RAG ingestion n8n workflow tweaks, document-rag
shared function fix, and local dev launch config.

Co-Authored-By: Claude Sonnet 5 <noreply@anthropic.com>
</commit_message>
<xml_diff>
--- a/docs/transferai-admin/Webinaire_Courrier_Confidentiel_PII_Roland_Coffi.pptx
+++ b/docs/transferai-admin/Webinaire_Courrier_Confidentiel_PII_Roland_Coffi.pptx
@@ -4,14 +4,14 @@
   <p:sldMasterIdLst>
     <p:sldMasterId id="2147483648" r:id="rId1"/>
   </p:sldMasterIdLst>
+  <p:notesMasterIdLst>
+    <p:notesMasterId r:id="rId5"/>
+  </p:notesMasterIdLst>
   <p:sldIdLst>
     <p:sldId id="256" r:id="rId2"/>
     <p:sldId id="257" r:id="rId3"/>
     <p:sldId id="258" r:id="rId4"/>
   </p:sldIdLst>
-  <p:notesMasterIdLst>
-    <p:notesMasterId r:id="rId5"/>
-  </p:notesMasterIdLst>
   <p:sldSz cx="12192000" cy="6858000"/>
   <p:notesSz cx="6858000" cy="12192000"/>
   <p:defaultTextStyle>
@@ -106,6 +106,11 @@
       </a:defRPr>
     </a:lvl9pPr>
   </p:defaultTextStyle>
+  <p:extLst>
+    <p:ext uri="{EFAFB233-063F-42B5-8137-9DF3F51BA10A}">
+      <p15:sldGuideLst xmlns:p15="http://schemas.microsoft.com/office/powerpoint/2012/main"/>
+    </p:ext>
+  </p:extLst>
 </p:presentation>
 </file>
 
@@ -131,234 +136,10 @@
           <a:chExt cx="0" cy="0"/>
         </a:xfrm>
       </p:grpSpPr>
-      <p:sp>
-        <p:nvSpPr>
-          <p:cNvPr id="2" name="Header Placeholder 1"/>
-          <p:cNvSpPr>
-            <a:spLocks noGrp="1"/>
-          </p:cNvSpPr>
-          <p:nvPr>
-            <p:ph type="hdr" sz="quarter"/>
-          </p:nvPr>
-        </p:nvSpPr>
-        <p:spPr>
-          <a:xfrm>
-            <a:off x="0" y="0"/>
-            <a:ext cx="2971800" cy="458788"/>
-          </a:xfrm>
-          <a:prstGeom prst="rect">
-            <a:avLst/>
-          </a:prstGeom>
-        </p:spPr>
-        <p:txBody>
-          <a:bodyPr vert="horz" lIns="91440" tIns="45720" rIns="91440" bIns="45720" rtlCol="0"/>
-          <a:lstStyle>
-            <a:lvl1pPr algn="l">
-              <a:defRPr sz="1200"/>
-            </a:lvl1pPr>
-          </a:lstStyle>
-          <a:p>
-            <a:endParaRPr lang="en-US"/>
-          </a:p>
-        </p:txBody>
-      </p:sp>
-      <p:sp>
-        <p:nvSpPr>
-          <p:cNvPr id="3" name="Date Placeholder 2"/>
-          <p:cNvSpPr>
-            <a:spLocks noGrp="1"/>
-          </p:cNvSpPr>
-          <p:nvPr>
-            <p:ph type="dt" idx="1"/>
-          </p:nvPr>
-        </p:nvSpPr>
-        <p:spPr>
-          <a:xfrm>
-            <a:off x="3884613" y="0"/>
-            <a:ext cx="2971800" cy="458788"/>
-          </a:xfrm>
-          <a:prstGeom prst="rect">
-            <a:avLst/>
-          </a:prstGeom>
-        </p:spPr>
-        <p:txBody>
-          <a:bodyPr vert="horz" lIns="91440" tIns="45720" rIns="91440" bIns="45720" rtlCol="0"/>
-          <a:lstStyle>
-            <a:lvl1pPr algn="r">
-              <a:defRPr sz="1200"/>
-            </a:lvl1pPr>
-          </a:lstStyle>
-          <a:p>
-            <a:fld id="{5282F153-3F37-0F45-9E97-73ACFA13230C}" type="datetimeFigureOut">
-              <a:rPr lang="en-US"/>
-              <a:t>7/23/19</a:t>
-            </a:fld>
-            <a:endParaRPr lang="en-US"/>
-          </a:p>
-        </p:txBody>
-      </p:sp>
-      <p:sp>
-        <p:nvSpPr>
-          <p:cNvPr id="4" name="Slide Image Placeholder 3"/>
-          <p:cNvSpPr>
-            <a:spLocks noGrp="1" noRot="1" noChangeAspect="1"/>
-          </p:cNvSpPr>
-          <p:nvPr>
-            <p:ph type="sldImg" idx="2"/>
-          </p:nvPr>
-        </p:nvSpPr>
-        <p:spPr>
-          <a:xfrm>
-            <a:off x="685800" y="1143000"/>
-            <a:ext cx="5486400" cy="3086100"/>
-          </a:xfrm>
-          <a:prstGeom prst="rect">
-            <a:avLst/>
-          </a:prstGeom>
-          <a:noFill/>
-          <a:ln w="12700">
-            <a:solidFill>
-              <a:prstClr val="black"/>
-            </a:solidFill>
-          </a:ln>
-        </p:spPr>
-        <p:txBody>
-          <a:bodyPr vert="horz" lIns="91440" tIns="45720" rIns="91440" bIns="45720" rtlCol="0" anchor="ctr"/>
-          <a:lstStyle/>
-          <a:p>
-            <a:endParaRPr lang="en-US"/>
-          </a:p>
-        </p:txBody>
-      </p:sp>
-      <p:sp>
-        <p:nvSpPr>
-          <p:cNvPr id="5" name="Notes Placeholder 4"/>
-          <p:cNvSpPr>
-            <a:spLocks noGrp="1"/>
-          </p:cNvSpPr>
-          <p:nvPr>
-            <p:ph type="body" sz="quarter" idx="3"/>
-          </p:nvPr>
-        </p:nvSpPr>
-        <p:spPr>
-          <a:xfrm>
-            <a:off x="685800" y="4400550"/>
-            <a:ext cx="5486400" cy="3600450"/>
-          </a:xfrm>
-          <a:prstGeom prst="rect">
-            <a:avLst/>
-          </a:prstGeom>
-        </p:spPr>
-        <p:txBody>
-          <a:bodyPr vert="horz" lIns="91440" tIns="45720" rIns="91440" bIns="45720" rtlCol="0"/>
-          <a:lstStyle/>
-          <a:p>
-            <a:pPr lvl="0"/>
-            <a:r>
-              <a:rPr lang="en-US"/>
-              <a:t>Click to edit Master text styles</a:t>
-            </a:r>
-          </a:p>
-          <a:p>
-            <a:pPr lvl="1"/>
-            <a:r>
-              <a:rPr lang="en-US"/>
-              <a:t>Second level</a:t>
-            </a:r>
-          </a:p>
-          <a:p>
-            <a:pPr lvl="2"/>
-            <a:r>
-              <a:rPr lang="en-US"/>
-              <a:t>Third level</a:t>
-            </a:r>
-          </a:p>
-          <a:p>
-            <a:pPr lvl="3"/>
-            <a:r>
-              <a:rPr lang="en-US"/>
-              <a:t>Fourth level</a:t>
-            </a:r>
-          </a:p>
-          <a:p>
-            <a:pPr lvl="4"/>
-            <a:r>
-              <a:rPr lang="en-US"/>
-              <a:t>Fifth level</a:t>
-            </a:r>
-          </a:p>
-        </p:txBody>
-      </p:sp>
-      <p:sp>
-        <p:nvSpPr>
-          <p:cNvPr id="6" name="Footer Placeholder 5"/>
-          <p:cNvSpPr>
-            <a:spLocks noGrp="1"/>
-          </p:cNvSpPr>
-          <p:nvPr>
-            <p:ph type="ftr" sz="quarter" idx="4"/>
-          </p:nvPr>
-        </p:nvSpPr>
-        <p:spPr>
-          <a:xfrm>
-            <a:off x="0" y="8685213"/>
-            <a:ext cx="2971800" cy="458787"/>
-          </a:xfrm>
-          <a:prstGeom prst="rect">
-            <a:avLst/>
-          </a:prstGeom>
-        </p:spPr>
-        <p:txBody>
-          <a:bodyPr vert="horz" lIns="91440" tIns="45720" rIns="91440" bIns="45720" rtlCol="0" anchor="b"/>
-          <a:lstStyle>
-            <a:lvl1pPr algn="l">
-              <a:defRPr sz="1200"/>
-            </a:lvl1pPr>
-          </a:lstStyle>
-          <a:p>
-            <a:endParaRPr lang="en-US"/>
-          </a:p>
-        </p:txBody>
-      </p:sp>
-      <p:sp>
-        <p:nvSpPr>
-          <p:cNvPr id="7" name="Slide Number Placeholder 6"/>
-          <p:cNvSpPr>
-            <a:spLocks noGrp="1"/>
-          </p:cNvSpPr>
-          <p:nvPr>
-            <p:ph type="sldNum" sz="quarter" idx="5"/>
-          </p:nvPr>
-        </p:nvSpPr>
-        <p:spPr>
-          <a:xfrm>
-            <a:off x="3884613" y="8685213"/>
-            <a:ext cx="2971800" cy="458787"/>
-          </a:xfrm>
-          <a:prstGeom prst="rect">
-            <a:avLst/>
-          </a:prstGeom>
-        </p:spPr>
-        <p:txBody>
-          <a:bodyPr vert="horz" lIns="91440" tIns="45720" rIns="91440" bIns="45720" rtlCol="0" anchor="b"/>
-          <a:lstStyle>
-            <a:lvl1pPr algn="r">
-              <a:defRPr sz="1200"/>
-            </a:lvl1pPr>
-          </a:lstStyle>
-          <a:p>
-            <a:fld id="{CE5E9CC1-C706-0F49-92D6-E571CC5EEA8F}" type="slidenum">
-              <a:rPr lang="en-US"/>
-              <a:t>‹#›</a:t>
-            </a:fld>
-            <a:endParaRPr lang="en-US"/>
-          </a:p>
-        </p:txBody>
-      </p:sp>
     </p:spTree>
     <p:extLst>
       <p:ext uri="{BB962C8B-B14F-4D97-AF65-F5344CB8AC3E}">
-        <p14:creationId xmlns:p14="http://schemas.microsoft.com/office/powerpoint/2010/main" val="1024086991"/>
+        <p14:creationId xmlns:p14="http://schemas.microsoft.com/office/powerpoint/2010/main" val="2299707693"/>
       </p:ext>
     </p:extLst>
   </p:cSld>
@@ -502,10 +283,6 @@
           <a:bodyPr/>
           <a:lstStyle/>
           <a:p>
-            <a:r>
-              <a:rPr lang="en-US" dirty="0"/>
-              <a:t/>
-            </a:r>
             <a:endParaRPr lang="en-US" dirty="0"/>
           </a:p>
         </p:txBody>
@@ -590,10 +367,6 @@
           <a:bodyPr/>
           <a:lstStyle/>
           <a:p>
-            <a:r>
-              <a:rPr lang="en-US" dirty="0"/>
-              <a:t/>
-            </a:r>
             <a:endParaRPr lang="en-US" dirty="0"/>
           </a:p>
         </p:txBody>
@@ -678,10 +451,6 @@
           <a:bodyPr/>
           <a:lstStyle/>
           <a:p>
-            <a:r>
-              <a:rPr lang="en-US" dirty="0"/>
-              <a:t/>
-            </a:r>
             <a:endParaRPr lang="en-US" dirty="0"/>
           </a:p>
         </p:txBody>
@@ -755,6 +524,11 @@
 <file path=ppt/slideMasters/slideMaster1.xml><?xml version="1.0" encoding="utf-8"?>
 <p:sldMaster xmlns:a="http://schemas.openxmlformats.org/drawingml/2006/main" xmlns:r="http://schemas.openxmlformats.org/officeDocument/2006/relationships" xmlns:p="http://schemas.openxmlformats.org/presentationml/2006/main">
   <p:cSld>
+    <p:bg>
+      <p:bgRef idx="1001">
+        <a:schemeClr val="bg1"/>
+      </p:bgRef>
+    </p:bg>
     <p:spTree>
       <p:nvGrpSpPr>
         <p:cNvPr id="1" name=""/>
@@ -1037,6 +811,7 @@
         <a:solidFill>
           <a:srgbClr val="10263F"/>
         </a:solidFill>
+        <a:effectLst/>
       </p:bgPr>
     </p:bg>
     <p:spTree>
@@ -1099,7 +874,7 @@
           <a:bodyPr wrap="square" rtlCol="0" anchor="ctr"/>
           <a:lstStyle/>
           <a:p>
-            <a:pPr algn="ctr" indent="0" marL="0">
+            <a:pPr marL="0" indent="0" algn="ctr">
               <a:buNone/>
             </a:pPr>
             <a:r>
@@ -1138,11 +913,11 @@
           <a:bodyPr wrap="square" rtlCol="0" anchor="ctr"/>
           <a:lstStyle/>
           <a:p>
-            <a:pPr indent="0" marL="0">
-              <a:buNone/>
-            </a:pPr>
-            <a:r>
-              <a:rPr lang="en-US" sz="4000" b="1" spc="50" kern="0" dirty="0">
+            <a:pPr marL="0" indent="0">
+              <a:buNone/>
+            </a:pPr>
+            <a:r>
+              <a:rPr lang="en-US" sz="4000" b="1" kern="0" spc="50" dirty="0">
                 <a:solidFill>
                   <a:srgbClr val="FFFFFF"/>
                 </a:solidFill>
@@ -1177,11 +952,11 @@
           <a:bodyPr wrap="square" rtlCol="0" anchor="ctr"/>
           <a:lstStyle/>
           <a:p>
-            <a:pPr indent="0" marL="0">
-              <a:buNone/>
-            </a:pPr>
-            <a:r>
-              <a:rPr lang="en-US" sz="4000" b="1" spc="50" kern="0" dirty="0">
+            <a:pPr marL="0" indent="0">
+              <a:buNone/>
+            </a:pPr>
+            <a:r>
+              <a:rPr lang="en-US" sz="4000" b="1" kern="0" spc="50" dirty="0">
                 <a:solidFill>
                   <a:srgbClr val="7C5CFC"/>
                 </a:solidFill>
@@ -1216,7 +991,7 @@
           <a:bodyPr wrap="square" rtlCol="0" anchor="ctr"/>
           <a:lstStyle/>
           <a:p>
-            <a:pPr indent="0" marL="0">
+            <a:pPr marL="0" indent="0">
               <a:buNone/>
             </a:pPr>
             <a:r>
@@ -1255,7 +1030,7 @@
           <a:bodyPr wrap="square" rtlCol="0" anchor="ctr"/>
           <a:lstStyle/>
           <a:p>
-            <a:pPr indent="0" marL="0">
+            <a:pPr marL="0" indent="0">
               <a:buNone/>
             </a:pPr>
             <a:r>
@@ -1294,7 +1069,7 @@
           <a:bodyPr wrap="square" rtlCol="0" anchor="ctr"/>
           <a:lstStyle/>
           <a:p>
-            <a:pPr indent="0" marL="0">
+            <a:pPr marL="0" indent="0">
               <a:buNone/>
             </a:pPr>
             <a:r>
@@ -1333,7 +1108,7 @@
           <a:bodyPr wrap="square" rtlCol="0" anchor="t"/>
           <a:lstStyle/>
           <a:p>
-            <a:pPr indent="0" marL="0">
+            <a:pPr marL="0" indent="0">
               <a:buNone/>
             </a:pPr>
             <a:r>
@@ -1372,7 +1147,7 @@
           <a:bodyPr wrap="square" rtlCol="0" anchor="ctr"/>
           <a:lstStyle/>
           <a:p>
-            <a:pPr indent="0" marL="0">
+            <a:pPr marL="0" indent="0">
               <a:buNone/>
             </a:pPr>
             <a:r>
@@ -1411,7 +1186,7 @@
           <a:bodyPr wrap="square" rtlCol="0" anchor="t"/>
           <a:lstStyle/>
           <a:p>
-            <a:pPr indent="0" marL="0">
+            <a:pPr marL="0" indent="0">
               <a:buNone/>
             </a:pPr>
             <a:r>
@@ -1450,7 +1225,7 @@
           <a:bodyPr wrap="square" rtlCol="0" anchor="ctr"/>
           <a:lstStyle/>
           <a:p>
-            <a:pPr indent="0" marL="0">
+            <a:pPr marL="0" indent="0">
               <a:buNone/>
             </a:pPr>
             <a:r>
@@ -1489,7 +1264,7 @@
           <a:bodyPr wrap="square" rtlCol="0" anchor="ctr"/>
           <a:lstStyle/>
           <a:p>
-            <a:pPr algn="r" indent="0" marL="0">
+            <a:pPr marL="0" indent="0" algn="r">
               <a:buNone/>
             </a:pPr>
             <a:r>
@@ -1523,6 +1298,7 @@
         <a:solidFill>
           <a:srgbClr val="10263F"/>
         </a:solidFill>
+        <a:effectLst/>
       </p:bgPr>
     </p:bg>
     <p:spTree>
@@ -1560,7 +1336,7 @@
           <a:bodyPr wrap="square" rtlCol="0" anchor="ctr"/>
           <a:lstStyle/>
           <a:p>
-            <a:pPr indent="0" marL="0">
+            <a:pPr marL="0" indent="0">
               <a:buNone/>
             </a:pPr>
             <a:r>
@@ -1599,7 +1375,7 @@
           <a:bodyPr wrap="square" rtlCol="0" anchor="ctr"/>
           <a:lstStyle/>
           <a:p>
-            <a:pPr indent="0" marL="0">
+            <a:pPr marL="0" indent="0">
               <a:buNone/>
             </a:pPr>
             <a:r>
@@ -1660,11 +1436,11 @@
           <a:bodyPr wrap="square" rtlCol="0" anchor="ctr"/>
           <a:lstStyle/>
           <a:p>
-            <a:pPr indent="0" marL="0">
-              <a:buNone/>
-            </a:pPr>
-            <a:r>
-              <a:rPr lang="en-US" sz="1100" b="1" spc="100" kern="0" dirty="0">
+            <a:pPr marL="0" indent="0">
+              <a:buNone/>
+            </a:pPr>
+            <a:r>
+              <a:rPr lang="en-US" sz="1100" b="1" kern="0" spc="100" dirty="0">
                 <a:solidFill>
                   <a:srgbClr val="7C5CFC"/>
                 </a:solidFill>
@@ -1699,7 +1475,7 @@
           <a:bodyPr wrap="square" rtlCol="0" anchor="t"/>
           <a:lstStyle/>
           <a:p>
-            <a:pPr indent="0" marL="0">
+            <a:pPr marL="0" indent="0">
               <a:buNone/>
             </a:pPr>
             <a:r>
@@ -1760,11 +1536,11 @@
           <a:bodyPr wrap="square" rtlCol="0" anchor="ctr"/>
           <a:lstStyle/>
           <a:p>
-            <a:pPr indent="0" marL="0">
-              <a:buNone/>
-            </a:pPr>
-            <a:r>
-              <a:rPr lang="en-US" sz="1100" b="1" spc="100" kern="0" dirty="0">
+            <a:pPr marL="0" indent="0">
+              <a:buNone/>
+            </a:pPr>
+            <a:r>
+              <a:rPr lang="en-US" sz="1100" b="1" kern="0" spc="100" dirty="0">
                 <a:solidFill>
                   <a:srgbClr val="7C5CFC"/>
                 </a:solidFill>
@@ -1772,7 +1548,7 @@
                 <a:ea typeface="Calibri" pitchFamily="34" charset="-122"/>
                 <a:cs typeface="Calibri" pitchFamily="34" charset="-120"/>
               </a:rPr>
-              <a:t>ENGLISH</a:t>
+              <a:t>RÔLE DANS LE PROCESSUS</a:t>
             </a:r>
             <a:endParaRPr lang="en-US" sz="1100" dirty="0"/>
           </a:p>
@@ -1799,11 +1575,11 @@
           <a:bodyPr wrap="square" rtlCol="0" anchor="t"/>
           <a:lstStyle/>
           <a:p>
-            <a:pPr indent="0" marL="0">
-              <a:buNone/>
-            </a:pPr>
-            <a:r>
-              <a:rPr lang="en-US" sz="1300" dirty="0">
+            <a:pPr marL="0" indent="0">
+              <a:buNone/>
+            </a:pPr>
+            <a:r>
+              <a:rPr lang="en-US" sz="1150" dirty="0">
                 <a:solidFill>
                   <a:srgbClr val="B7C0D8"/>
                 </a:solidFill>
@@ -1811,9 +1587,9 @@
                 <a:ea typeface="Calibri" pitchFamily="34" charset="-122"/>
                 <a:cs typeface="Calibri" pitchFamily="34" charset="-120"/>
               </a:rPr>
-              <a:t>Personally Identifiable Information (PII): any data that can identify a specific person — name, address, phone number, passport, case reference…</a:t>
-            </a:r>
-            <a:endParaRPr lang="en-US" sz="1300" dirty="0"/>
+              <a:t>Avant tout envoi à l'IA, chaque PII détectée dans le texte est remplacée par un jeton neutre (ex. [PERSONNE_1], [REFERENCE_1]). L'IA rédige avec ces jetons, sans jamais voir la donnée réelle — qui n'est restaurée qu'à la toute fin, pour un humain autorisé.</a:t>
+            </a:r>
+            <a:endParaRPr lang="en-US" sz="1150" dirty="0"/>
           </a:p>
         </p:txBody>
       </p:sp>
@@ -1838,7 +1614,7 @@
           <a:bodyPr wrap="square" rtlCol="0" anchor="ctr"/>
           <a:lstStyle/>
           <a:p>
-            <a:pPr indent="0" marL="0">
+            <a:pPr marL="0" indent="0">
               <a:buNone/>
             </a:pPr>
             <a:r>
@@ -1880,14 +1656,14 @@
       </p:sp>
       <p:pic>
         <p:nvPicPr>
-          <p:cNvPr id="12" name="Image 0" descr="/private/tmp/claude-501/-Users-marius-ayoro/7f816881-553d-470c-99ea-a412f0e083b6/scratchpad/cas_usage_pii/pipeline_schema.png">    </p:cNvPr>
+          <p:cNvPr id="12" name="Image 0" descr="/private/tmp/claude-501/-Users-marius-ayoro/7f816881-553d-470c-99ea-a412f0e083b6/scratchpad/cas_usage_pii/pipeline_schema.png"/>
           <p:cNvPicPr>
             <a:picLocks noChangeAspect="1"/>
           </p:cNvPicPr>
           <p:nvPr/>
         </p:nvPicPr>
         <p:blipFill>
-          <a:blip r:embed="rId1"/>
+          <a:blip r:embed="rId3"/>
           <a:stretch>
             <a:fillRect/>
           </a:stretch>
@@ -1923,7 +1699,7 @@
           <a:bodyPr wrap="square" rtlCol="0" anchor="ctr"/>
           <a:lstStyle/>
           <a:p>
-            <a:pPr indent="0" marL="0">
+            <a:pPr marL="0" indent="0">
               <a:buNone/>
             </a:pPr>
             <a:r>
@@ -1962,7 +1738,7 @@
           <a:bodyPr wrap="square" rtlCol="0" anchor="ctr"/>
           <a:lstStyle/>
           <a:p>
-            <a:pPr algn="r" indent="0" marL="0">
+            <a:pPr marL="0" indent="0" algn="r">
               <a:buNone/>
             </a:pPr>
             <a:r>
@@ -1996,6 +1772,7 @@
         <a:solidFill>
           <a:srgbClr val="10263F"/>
         </a:solidFill>
+        <a:effectLst/>
       </p:bgPr>
     </p:bg>
     <p:spTree>
@@ -2033,7 +1810,7 @@
           <a:bodyPr wrap="square" rtlCol="0" anchor="ctr"/>
           <a:lstStyle/>
           <a:p>
-            <a:pPr indent="0" marL="0">
+            <a:pPr marL="0" indent="0">
               <a:buNone/>
             </a:pPr>
             <a:r>
@@ -2072,7 +1849,7 @@
           <a:bodyPr wrap="square" rtlCol="0" anchor="ctr"/>
           <a:lstStyle/>
           <a:p>
-            <a:pPr indent="0" marL="0">
+            <a:pPr marL="0" indent="0">
               <a:buNone/>
             </a:pPr>
             <a:r>
@@ -2133,7 +1910,7 @@
           <a:bodyPr wrap="square" rtlCol="0" anchor="ctr"/>
           <a:lstStyle/>
           <a:p>
-            <a:pPr algn="ctr" indent="0" marL="0">
+            <a:pPr marL="0" indent="0" algn="ctr">
               <a:buNone/>
             </a:pPr>
             <a:r>
@@ -2172,7 +1949,7 @@
           <a:bodyPr wrap="square" rtlCol="0" anchor="ctr"/>
           <a:lstStyle/>
           <a:p>
-            <a:pPr algn="ctr" indent="0" marL="0">
+            <a:pPr marL="0" indent="0" algn="ctr">
               <a:buNone/>
             </a:pPr>
             <a:r>
@@ -2233,7 +2010,7 @@
           <a:bodyPr wrap="square" rtlCol="0" anchor="ctr"/>
           <a:lstStyle/>
           <a:p>
-            <a:pPr algn="ctr" indent="0" marL="0">
+            <a:pPr marL="0" indent="0" algn="ctr">
               <a:buNone/>
             </a:pPr>
             <a:r>
@@ -2272,7 +2049,7 @@
           <a:bodyPr wrap="square" rtlCol="0" anchor="ctr"/>
           <a:lstStyle/>
           <a:p>
-            <a:pPr algn="ctr" indent="0" marL="0">
+            <a:pPr marL="0" indent="0" algn="ctr">
               <a:buNone/>
             </a:pPr>
             <a:r>
@@ -2333,7 +2110,7 @@
           <a:bodyPr wrap="square" rtlCol="0" anchor="ctr"/>
           <a:lstStyle/>
           <a:p>
-            <a:pPr algn="ctr" indent="0" marL="0">
+            <a:pPr marL="0" indent="0" algn="ctr">
               <a:buNone/>
             </a:pPr>
             <a:r>
@@ -2372,7 +2149,7 @@
           <a:bodyPr wrap="square" rtlCol="0" anchor="ctr"/>
           <a:lstStyle/>
           <a:p>
-            <a:pPr algn="ctr" indent="0" marL="0">
+            <a:pPr marL="0" indent="0" algn="ctr">
               <a:buNone/>
             </a:pPr>
             <a:r>
@@ -2433,7 +2210,7 @@
           <a:bodyPr wrap="square" rtlCol="0" anchor="ctr"/>
           <a:lstStyle/>
           <a:p>
-            <a:pPr algn="ctr" indent="0" marL="0">
+            <a:pPr marL="0" indent="0" algn="ctr">
               <a:buNone/>
             </a:pPr>
             <a:r>
@@ -2472,7 +2249,7 @@
           <a:bodyPr wrap="square" rtlCol="0" anchor="ctr"/>
           <a:lstStyle/>
           <a:p>
-            <a:pPr algn="ctr" indent="0" marL="0">
+            <a:pPr marL="0" indent="0" algn="ctr">
               <a:buNone/>
             </a:pPr>
             <a:r>
@@ -2511,7 +2288,7 @@
           <a:bodyPr wrap="square" rtlCol="0" anchor="ctr"/>
           <a:lstStyle/>
           <a:p>
-            <a:pPr indent="0" marL="0">
+            <a:pPr marL="0" indent="0">
               <a:buNone/>
             </a:pPr>
             <a:r>
@@ -2570,7 +2347,7 @@
           <a:bodyPr wrap="square" rtlCol="0" anchor="t"/>
           <a:lstStyle/>
           <a:p>
-            <a:pPr indent="0" marL="0">
+            <a:pPr marL="0" indent="0">
               <a:buNone/>
             </a:pPr>
             <a:r>
@@ -2629,7 +2406,7 @@
           <a:bodyPr wrap="square" rtlCol="0" anchor="t"/>
           <a:lstStyle/>
           <a:p>
-            <a:pPr indent="0" marL="0">
+            <a:pPr marL="0" indent="0">
               <a:buNone/>
             </a:pPr>
             <a:r>
@@ -2688,7 +2465,7 @@
           <a:bodyPr wrap="square" rtlCol="0" anchor="t"/>
           <a:lstStyle/>
           <a:p>
-            <a:pPr indent="0" marL="0">
+            <a:pPr marL="0" indent="0">
               <a:buNone/>
             </a:pPr>
             <a:r>
@@ -2747,7 +2524,7 @@
           <a:bodyPr wrap="square" rtlCol="0" anchor="t"/>
           <a:lstStyle/>
           <a:p>
-            <a:pPr indent="0" marL="0">
+            <a:pPr marL="0" indent="0">
               <a:buNone/>
             </a:pPr>
             <a:r>
@@ -2808,7 +2585,7 @@
           <a:bodyPr wrap="square" rtlCol="0" anchor="ctr"/>
           <a:lstStyle/>
           <a:p>
-            <a:pPr indent="0" marL="0">
+            <a:pPr marL="0" indent="0">
               <a:buNone/>
             </a:pPr>
             <a:r>
@@ -2847,7 +2624,7 @@
           <a:bodyPr wrap="square" rtlCol="0" anchor="ctr"/>
           <a:lstStyle/>
           <a:p>
-            <a:pPr indent="0" marL="0">
+            <a:pPr marL="0" indent="0">
               <a:buNone/>
             </a:pPr>
             <a:r>
@@ -2859,7 +2636,62 @@
                 <a:ea typeface="Calibri" pitchFamily="34" charset="-122"/>
                 <a:cs typeface="Calibri" pitchFamily="34" charset="-120"/>
               </a:rPr>
-              <a:t>Prochaine étape : formation « L'IA au Bureau » — 28-29 juillet 2026, Riviera 3, Abidjan</a:t>
+              <a:t>Prochaine étape : formation « L'IA au Bureau » — 28-29 juillet 2026, </a:t>
+            </a:r>
+            <a:r>
+              <a:rPr lang="en-US" sz="1100" dirty="0" err="1">
+                <a:solidFill>
+                  <a:srgbClr val="EDE9FF"/>
+                </a:solidFill>
+                <a:latin typeface="Calibri" pitchFamily="34" charset="0"/>
+                <a:ea typeface="Calibri" pitchFamily="34" charset="-122"/>
+                <a:cs typeface="Calibri" pitchFamily="34" charset="-120"/>
+              </a:rPr>
+              <a:t>ou</a:t>
+            </a:r>
+            <a:r>
+              <a:rPr lang="en-US" sz="1100" dirty="0">
+                <a:solidFill>
+                  <a:srgbClr val="EDE9FF"/>
+                </a:solidFill>
+                <a:latin typeface="Calibri" pitchFamily="34" charset="0"/>
+                <a:ea typeface="Calibri" pitchFamily="34" charset="-122"/>
+                <a:cs typeface="Calibri" pitchFamily="34" charset="-120"/>
+              </a:rPr>
+              <a:t> 10-11 </a:t>
+            </a:r>
+            <a:r>
+              <a:rPr lang="en-US" sz="1100" dirty="0" err="1">
+                <a:solidFill>
+                  <a:srgbClr val="EDE9FF"/>
+                </a:solidFill>
+                <a:latin typeface="Calibri" pitchFamily="34" charset="0"/>
+                <a:ea typeface="Calibri" pitchFamily="34" charset="-122"/>
+                <a:cs typeface="Calibri" pitchFamily="34" charset="-120"/>
+              </a:rPr>
+              <a:t>aout</a:t>
+            </a:r>
+            <a:r>
+              <a:rPr lang="en-US" sz="1100">
+                <a:solidFill>
+                  <a:srgbClr val="EDE9FF"/>
+                </a:solidFill>
+                <a:latin typeface="Calibri" pitchFamily="34" charset="0"/>
+                <a:ea typeface="Calibri" pitchFamily="34" charset="-122"/>
+                <a:cs typeface="Calibri" pitchFamily="34" charset="-120"/>
+              </a:rPr>
+              <a:t> 2026 </a:t>
+            </a:r>
+            <a:r>
+              <a:rPr lang="en-US" sz="1100" dirty="0">
+                <a:solidFill>
+                  <a:srgbClr val="EDE9FF"/>
+                </a:solidFill>
+                <a:latin typeface="Calibri" pitchFamily="34" charset="0"/>
+                <a:ea typeface="Calibri" pitchFamily="34" charset="-122"/>
+                <a:cs typeface="Calibri" pitchFamily="34" charset="-120"/>
+              </a:rPr>
+              <a:t>Riviera 3, Abidjan</a:t>
             </a:r>
             <a:endParaRPr lang="en-US" sz="1100" dirty="0"/>
           </a:p>
@@ -2886,7 +2718,7 @@
           <a:bodyPr wrap="square" rtlCol="0" anchor="ctr"/>
           <a:lstStyle/>
           <a:p>
-            <a:pPr indent="0" marL="0">
+            <a:pPr marL="0" indent="0">
               <a:buNone/>
             </a:pPr>
             <a:r>
@@ -2925,7 +2757,7 @@
           <a:bodyPr wrap="square" rtlCol="0" anchor="ctr"/>
           <a:lstStyle/>
           <a:p>
-            <a:pPr algn="r" indent="0" marL="0">
+            <a:pPr marL="0" indent="0" algn="r">
               <a:buNone/>
             </a:pPr>
             <a:r>
@@ -3244,4 +3076,319 @@
     </a:ext>
   </a:extLst>
 </a:theme>
+</file>
+
+<file path=ppt/theme/theme2.xml><?xml version="1.0" encoding="utf-8"?>
+<a:theme xmlns:a="http://schemas.openxmlformats.org/drawingml/2006/main" name="Office Theme">
+  <a:themeElements>
+    <a:clrScheme name="Office">
+      <a:dk1>
+        <a:sysClr val="windowText" lastClr="000000"/>
+      </a:dk1>
+      <a:lt1>
+        <a:sysClr val="window" lastClr="FFFFFF"/>
+      </a:lt1>
+      <a:dk2>
+        <a:srgbClr val="0E2841"/>
+      </a:dk2>
+      <a:lt2>
+        <a:srgbClr val="E8E8E8"/>
+      </a:lt2>
+      <a:accent1>
+        <a:srgbClr val="156082"/>
+      </a:accent1>
+      <a:accent2>
+        <a:srgbClr val="E97132"/>
+      </a:accent2>
+      <a:accent3>
+        <a:srgbClr val="196B24"/>
+      </a:accent3>
+      <a:accent4>
+        <a:srgbClr val="0F9ED5"/>
+      </a:accent4>
+      <a:accent5>
+        <a:srgbClr val="A02B93"/>
+      </a:accent5>
+      <a:accent6>
+        <a:srgbClr val="4EA72E"/>
+      </a:accent6>
+      <a:hlink>
+        <a:srgbClr val="467886"/>
+      </a:hlink>
+      <a:folHlink>
+        <a:srgbClr val="96607D"/>
+      </a:folHlink>
+    </a:clrScheme>
+    <a:fontScheme name="Office">
+      <a:majorFont>
+        <a:latin typeface="Aptos Display" panose="02110004020202020204"/>
+        <a:ea typeface=""/>
+        <a:cs typeface=""/>
+        <a:font script="Jpan" typeface="游ゴシック Light"/>
+        <a:font script="Hang" typeface="맑은 고딕"/>
+        <a:font script="Hans" typeface="等线 Light"/>
+        <a:font script="Hant" typeface="新細明體"/>
+        <a:font script="Arab" typeface="Times New Roman"/>
+        <a:font script="Hebr" typeface="Times New Roman"/>
+        <a:font script="Thai" typeface="Angsana New"/>
+        <a:font script="Ethi" typeface="Nyala"/>
+        <a:font script="Beng" typeface="Vrinda"/>
+        <a:font script="Gujr" typeface="Shruti"/>
+        <a:font script="Khmr" typeface="MoolBoran"/>
+        <a:font script="Knda" typeface="Tunga"/>
+        <a:font script="Guru" typeface="Raavi"/>
+        <a:font script="Cans" typeface="Euphemia"/>
+        <a:font script="Cher" typeface="Plantagenet Cherokee"/>
+        <a:font script="Yiii" typeface="Microsoft Yi Baiti"/>
+        <a:font script="Tibt" typeface="Microsoft Himalaya"/>
+        <a:font script="Thaa" typeface="MV Boli"/>
+        <a:font script="Deva" typeface="Mangal"/>
+        <a:font script="Telu" typeface="Gautami"/>
+        <a:font script="Taml" typeface="Latha"/>
+        <a:font script="Syrc" typeface="Estrangelo Edessa"/>
+        <a:font script="Orya" typeface="Kalinga"/>
+        <a:font script="Mlym" typeface="Kartika"/>
+        <a:font script="Laoo" typeface="DokChampa"/>
+        <a:font script="Sinh" typeface="Iskoola Pota"/>
+        <a:font script="Mong" typeface="Mongolian Baiti"/>
+        <a:font script="Viet" typeface="Times New Roman"/>
+        <a:font script="Uigh" typeface="Microsoft Uighur"/>
+        <a:font script="Geor" typeface="Sylfaen"/>
+        <a:font script="Armn" typeface="Arial"/>
+        <a:font script="Bugi" typeface="Leelawadee UI"/>
+        <a:font script="Bopo" typeface="Microsoft JhengHei"/>
+        <a:font script="Java" typeface="Javanese Text"/>
+        <a:font script="Lisu" typeface="Segoe UI"/>
+        <a:font script="Mymr" typeface="Myanmar Text"/>
+        <a:font script="Nkoo" typeface="Ebrima"/>
+        <a:font script="Olck" typeface="Nirmala UI"/>
+        <a:font script="Osma" typeface="Ebrima"/>
+        <a:font script="Phag" typeface="Phagspa"/>
+        <a:font script="Syrn" typeface="Estrangelo Edessa"/>
+        <a:font script="Syrj" typeface="Estrangelo Edessa"/>
+        <a:font script="Syre" typeface="Estrangelo Edessa"/>
+        <a:font script="Sora" typeface="Nirmala UI"/>
+        <a:font script="Tale" typeface="Microsoft Tai Le"/>
+        <a:font script="Talu" typeface="Microsoft New Tai Lue"/>
+        <a:font script="Tfng" typeface="Ebrima"/>
+      </a:majorFont>
+      <a:minorFont>
+        <a:latin typeface="Aptos" panose="02110004020202020204"/>
+        <a:ea typeface=""/>
+        <a:cs typeface=""/>
+        <a:font script="Jpan" typeface="游ゴシック"/>
+        <a:font script="Hang" typeface="맑은 고딕"/>
+        <a:font script="Hans" typeface="等线"/>
+        <a:font script="Hant" typeface="新細明體"/>
+        <a:font script="Arab" typeface="Arial"/>
+        <a:font script="Hebr" typeface="Arial"/>
+        <a:font script="Thai" typeface="Cordia New"/>
+        <a:font script="Ethi" typeface="Nyala"/>
+        <a:font script="Beng" typeface="Vrinda"/>
+        <a:font script="Gujr" typeface="Shruti"/>
+        <a:font script="Khmr" typeface="DaunPenh"/>
+        <a:font script="Knda" typeface="Tunga"/>
+        <a:font script="Guru" typeface="Raavi"/>
+        <a:font script="Cans" typeface="Euphemia"/>
+        <a:font script="Cher" typeface="Plantagenet Cherokee"/>
+        <a:font script="Yiii" typeface="Microsoft Yi Baiti"/>
+        <a:font script="Tibt" typeface="Microsoft Himalaya"/>
+        <a:font script="Thaa" typeface="MV Boli"/>
+        <a:font script="Deva" typeface="Mangal"/>
+        <a:font script="Telu" typeface="Gautami"/>
+        <a:font script="Taml" typeface="Latha"/>
+        <a:font script="Syrc" typeface="Estrangelo Edessa"/>
+        <a:font script="Orya" typeface="Kalinga"/>
+        <a:font script="Mlym" typeface="Kartika"/>
+        <a:font script="Laoo" typeface="DokChampa"/>
+        <a:font script="Sinh" typeface="Iskoola Pota"/>
+        <a:font script="Mong" typeface="Mongolian Baiti"/>
+        <a:font script="Viet" typeface="Arial"/>
+        <a:font script="Uigh" typeface="Microsoft Uighur"/>
+        <a:font script="Geor" typeface="Sylfaen"/>
+        <a:font script="Armn" typeface="Arial"/>
+        <a:font script="Bugi" typeface="Leelawadee UI"/>
+        <a:font script="Bopo" typeface="Microsoft JhengHei"/>
+        <a:font script="Java" typeface="Javanese Text"/>
+        <a:font script="Lisu" typeface="Segoe UI"/>
+        <a:font script="Mymr" typeface="Myanmar Text"/>
+        <a:font script="Nkoo" typeface="Ebrima"/>
+        <a:font script="Olck" typeface="Nirmala UI"/>
+        <a:font script="Osma" typeface="Ebrima"/>
+        <a:font script="Phag" typeface="Phagspa"/>
+        <a:font script="Syrn" typeface="Estrangelo Edessa"/>
+        <a:font script="Syrj" typeface="Estrangelo Edessa"/>
+        <a:font script="Syre" typeface="Estrangelo Edessa"/>
+        <a:font script="Sora" typeface="Nirmala UI"/>
+        <a:font script="Tale" typeface="Microsoft Tai Le"/>
+        <a:font script="Talu" typeface="Microsoft New Tai Lue"/>
+        <a:font script="Tfng" typeface="Ebrima"/>
+      </a:minorFont>
+    </a:fontScheme>
+    <a:fmtScheme name="Office">
+      <a:fillStyleLst>
+        <a:solidFill>
+          <a:schemeClr val="phClr"/>
+        </a:solidFill>
+        <a:gradFill rotWithShape="1">
+          <a:gsLst>
+            <a:gs pos="0">
+              <a:schemeClr val="phClr">
+                <a:lumMod val="110000"/>
+                <a:satMod val="105000"/>
+                <a:tint val="67000"/>
+              </a:schemeClr>
+            </a:gs>
+            <a:gs pos="50000">
+              <a:schemeClr val="phClr">
+                <a:lumMod val="105000"/>
+                <a:satMod val="103000"/>
+                <a:tint val="73000"/>
+              </a:schemeClr>
+            </a:gs>
+            <a:gs pos="100000">
+              <a:schemeClr val="phClr">
+                <a:lumMod val="105000"/>
+                <a:satMod val="109000"/>
+                <a:tint val="81000"/>
+              </a:schemeClr>
+            </a:gs>
+          </a:gsLst>
+          <a:lin ang="5400000" scaled="0"/>
+        </a:gradFill>
+        <a:gradFill rotWithShape="1">
+          <a:gsLst>
+            <a:gs pos="0">
+              <a:schemeClr val="phClr">
+                <a:satMod val="103000"/>
+                <a:lumMod val="102000"/>
+                <a:tint val="94000"/>
+              </a:schemeClr>
+            </a:gs>
+            <a:gs pos="50000">
+              <a:schemeClr val="phClr">
+                <a:satMod val="110000"/>
+                <a:lumMod val="100000"/>
+                <a:shade val="100000"/>
+              </a:schemeClr>
+            </a:gs>
+            <a:gs pos="100000">
+              <a:schemeClr val="phClr">
+                <a:lumMod val="99000"/>
+                <a:satMod val="120000"/>
+                <a:shade val="78000"/>
+              </a:schemeClr>
+            </a:gs>
+          </a:gsLst>
+          <a:lin ang="5400000" scaled="0"/>
+        </a:gradFill>
+      </a:fillStyleLst>
+      <a:lnStyleLst>
+        <a:ln w="12700" cap="flat" cmpd="sng" algn="ctr">
+          <a:solidFill>
+            <a:schemeClr val="phClr"/>
+          </a:solidFill>
+          <a:prstDash val="solid"/>
+          <a:miter lim="800000"/>
+        </a:ln>
+        <a:ln w="19050" cap="flat" cmpd="sng" algn="ctr">
+          <a:solidFill>
+            <a:schemeClr val="phClr"/>
+          </a:solidFill>
+          <a:prstDash val="solid"/>
+          <a:miter lim="800000"/>
+        </a:ln>
+        <a:ln w="25400" cap="flat" cmpd="sng" algn="ctr">
+          <a:solidFill>
+            <a:schemeClr val="phClr"/>
+          </a:solidFill>
+          <a:prstDash val="solid"/>
+          <a:miter lim="800000"/>
+        </a:ln>
+      </a:lnStyleLst>
+      <a:effectStyleLst>
+        <a:effectStyle>
+          <a:effectLst/>
+        </a:effectStyle>
+        <a:effectStyle>
+          <a:effectLst/>
+        </a:effectStyle>
+        <a:effectStyle>
+          <a:effectLst>
+            <a:outerShdw blurRad="57150" dist="19050" dir="5400000" algn="ctr" rotWithShape="0">
+              <a:srgbClr val="000000">
+                <a:alpha val="63000"/>
+              </a:srgbClr>
+            </a:outerShdw>
+          </a:effectLst>
+        </a:effectStyle>
+      </a:effectStyleLst>
+      <a:bgFillStyleLst>
+        <a:solidFill>
+          <a:schemeClr val="phClr"/>
+        </a:solidFill>
+        <a:solidFill>
+          <a:schemeClr val="phClr">
+            <a:tint val="95000"/>
+            <a:satMod val="170000"/>
+          </a:schemeClr>
+        </a:solidFill>
+        <a:gradFill rotWithShape="1">
+          <a:gsLst>
+            <a:gs pos="0">
+              <a:schemeClr val="phClr">
+                <a:tint val="93000"/>
+                <a:satMod val="150000"/>
+                <a:shade val="98000"/>
+                <a:lumMod val="102000"/>
+              </a:schemeClr>
+            </a:gs>
+            <a:gs pos="50000">
+              <a:schemeClr val="phClr">
+                <a:tint val="98000"/>
+                <a:satMod val="130000"/>
+                <a:shade val="90000"/>
+                <a:lumMod val="103000"/>
+              </a:schemeClr>
+            </a:gs>
+            <a:gs pos="100000">
+              <a:schemeClr val="phClr">
+                <a:shade val="63000"/>
+                <a:satMod val="120000"/>
+              </a:schemeClr>
+            </a:gs>
+          </a:gsLst>
+          <a:lin ang="5400000" scaled="0"/>
+        </a:gradFill>
+      </a:bgFillStyleLst>
+    </a:fmtScheme>
+  </a:themeElements>
+  <a:objectDefaults>
+    <a:lnDef>
+      <a:spPr/>
+      <a:bodyPr/>
+      <a:lstStyle/>
+      <a:style>
+        <a:lnRef idx="2">
+          <a:schemeClr val="accent1"/>
+        </a:lnRef>
+        <a:fillRef idx="0">
+          <a:schemeClr val="accent1"/>
+        </a:fillRef>
+        <a:effectRef idx="1">
+          <a:schemeClr val="accent1"/>
+        </a:effectRef>
+        <a:fontRef idx="minor">
+          <a:schemeClr val="tx1"/>
+        </a:fontRef>
+      </a:style>
+    </a:lnDef>
+  </a:objectDefaults>
+  <a:extraClrSchemeLst/>
+  <a:extLst>
+    <a:ext uri="{05A4C25C-085E-4340-85A3-A5531E510DB2}">
+      <thm15:themeFamily xmlns:thm15="http://schemas.microsoft.com/office/thememl/2012/main" name="Office Theme" id="{2E142A2C-CD16-42D6-873A-C26D2A0506FA}" vid="{1BDDFF52-6CD6-40A5-AB3C-68EB2F1E4D0A}"/>
+    </a:ext>
+  </a:extLst>
+</a:theme>
 </file>
</xml_diff>

<commit_message>
Étend le deck webinaire Courrier PII à 5 slides (ROI + CR Réunion Internationale)
Ajoute une slide Bénéfices & ROI et une slide sur le workflow CR Réunion
Internationale (pipeline + exemple avant/après pseudonymisation), avec un
encadré bénéfices diplomatie plutôt qu'un détail technique interne.

Co-Authored-By: Claude Sonnet 5 <noreply@anthropic.com>
</commit_message>
<xml_diff>
--- a/docs/transferai-admin/Webinaire_Courrier_Confidentiel_PII_Roland_Coffi.pptx
+++ b/docs/transferai-admin/Webinaire_Courrier_Confidentiel_PII_Roland_Coffi.pptx
@@ -4,14 +4,16 @@
   <p:sldMasterIdLst>
     <p:sldMasterId id="2147483648" r:id="rId1"/>
   </p:sldMasterIdLst>
-  <p:notesMasterIdLst>
-    <p:notesMasterId r:id="rId5"/>
-  </p:notesMasterIdLst>
   <p:sldIdLst>
     <p:sldId id="256" r:id="rId2"/>
     <p:sldId id="257" r:id="rId3"/>
     <p:sldId id="258" r:id="rId4"/>
+    <p:sldId id="259" r:id="rId10"/>
+    <p:sldId id="260" r:id="rId11"/>
   </p:sldIdLst>
+  <p:notesMasterIdLst>
+    <p:notesMasterId r:id="rId5"/>
+  </p:notesMasterIdLst>
   <p:sldSz cx="12192000" cy="6858000"/>
   <p:notesSz cx="6858000" cy="12192000"/>
   <p:defaultTextStyle>
@@ -106,11 +108,6 @@
       </a:defRPr>
     </a:lvl9pPr>
   </p:defaultTextStyle>
-  <p:extLst>
-    <p:ext uri="{EFAFB233-063F-42B5-8137-9DF3F51BA10A}">
-      <p15:sldGuideLst xmlns:p15="http://schemas.microsoft.com/office/powerpoint/2012/main"/>
-    </p:ext>
-  </p:extLst>
 </p:presentation>
 </file>
 
@@ -136,10 +133,234 @@
           <a:chExt cx="0" cy="0"/>
         </a:xfrm>
       </p:grpSpPr>
+      <p:sp>
+        <p:nvSpPr>
+          <p:cNvPr id="2" name="Header Placeholder 1"/>
+          <p:cNvSpPr>
+            <a:spLocks noGrp="1"/>
+          </p:cNvSpPr>
+          <p:nvPr>
+            <p:ph type="hdr" sz="quarter"/>
+          </p:nvPr>
+        </p:nvSpPr>
+        <p:spPr>
+          <a:xfrm>
+            <a:off x="0" y="0"/>
+            <a:ext cx="2971800" cy="458788"/>
+          </a:xfrm>
+          <a:prstGeom prst="rect">
+            <a:avLst/>
+          </a:prstGeom>
+        </p:spPr>
+        <p:txBody>
+          <a:bodyPr vert="horz" lIns="91440" tIns="45720" rIns="91440" bIns="45720" rtlCol="0"/>
+          <a:lstStyle>
+            <a:lvl1pPr algn="l">
+              <a:defRPr sz="1200"/>
+            </a:lvl1pPr>
+          </a:lstStyle>
+          <a:p>
+            <a:endParaRPr lang="en-US"/>
+          </a:p>
+        </p:txBody>
+      </p:sp>
+      <p:sp>
+        <p:nvSpPr>
+          <p:cNvPr id="3" name="Date Placeholder 2"/>
+          <p:cNvSpPr>
+            <a:spLocks noGrp="1"/>
+          </p:cNvSpPr>
+          <p:nvPr>
+            <p:ph type="dt" idx="1"/>
+          </p:nvPr>
+        </p:nvSpPr>
+        <p:spPr>
+          <a:xfrm>
+            <a:off x="3884613" y="0"/>
+            <a:ext cx="2971800" cy="458788"/>
+          </a:xfrm>
+          <a:prstGeom prst="rect">
+            <a:avLst/>
+          </a:prstGeom>
+        </p:spPr>
+        <p:txBody>
+          <a:bodyPr vert="horz" lIns="91440" tIns="45720" rIns="91440" bIns="45720" rtlCol="0"/>
+          <a:lstStyle>
+            <a:lvl1pPr algn="r">
+              <a:defRPr sz="1200"/>
+            </a:lvl1pPr>
+          </a:lstStyle>
+          <a:p>
+            <a:fld id="{5282F153-3F37-0F45-9E97-73ACFA13230C}" type="datetimeFigureOut">
+              <a:rPr lang="en-US"/>
+              <a:t>7/23/19</a:t>
+            </a:fld>
+            <a:endParaRPr lang="en-US"/>
+          </a:p>
+        </p:txBody>
+      </p:sp>
+      <p:sp>
+        <p:nvSpPr>
+          <p:cNvPr id="4" name="Slide Image Placeholder 3"/>
+          <p:cNvSpPr>
+            <a:spLocks noGrp="1" noRot="1" noChangeAspect="1"/>
+          </p:cNvSpPr>
+          <p:nvPr>
+            <p:ph type="sldImg" idx="2"/>
+          </p:nvPr>
+        </p:nvSpPr>
+        <p:spPr>
+          <a:xfrm>
+            <a:off x="685800" y="1143000"/>
+            <a:ext cx="5486400" cy="3086100"/>
+          </a:xfrm>
+          <a:prstGeom prst="rect">
+            <a:avLst/>
+          </a:prstGeom>
+          <a:noFill/>
+          <a:ln w="12700">
+            <a:solidFill>
+              <a:prstClr val="black"/>
+            </a:solidFill>
+          </a:ln>
+        </p:spPr>
+        <p:txBody>
+          <a:bodyPr vert="horz" lIns="91440" tIns="45720" rIns="91440" bIns="45720" rtlCol="0" anchor="ctr"/>
+          <a:lstStyle/>
+          <a:p>
+            <a:endParaRPr lang="en-US"/>
+          </a:p>
+        </p:txBody>
+      </p:sp>
+      <p:sp>
+        <p:nvSpPr>
+          <p:cNvPr id="5" name="Notes Placeholder 4"/>
+          <p:cNvSpPr>
+            <a:spLocks noGrp="1"/>
+          </p:cNvSpPr>
+          <p:nvPr>
+            <p:ph type="body" sz="quarter" idx="3"/>
+          </p:nvPr>
+        </p:nvSpPr>
+        <p:spPr>
+          <a:xfrm>
+            <a:off x="685800" y="4400550"/>
+            <a:ext cx="5486400" cy="3600450"/>
+          </a:xfrm>
+          <a:prstGeom prst="rect">
+            <a:avLst/>
+          </a:prstGeom>
+        </p:spPr>
+        <p:txBody>
+          <a:bodyPr vert="horz" lIns="91440" tIns="45720" rIns="91440" bIns="45720" rtlCol="0"/>
+          <a:lstStyle/>
+          <a:p>
+            <a:pPr lvl="0"/>
+            <a:r>
+              <a:rPr lang="en-US"/>
+              <a:t>Click to edit Master text styles</a:t>
+            </a:r>
+          </a:p>
+          <a:p>
+            <a:pPr lvl="1"/>
+            <a:r>
+              <a:rPr lang="en-US"/>
+              <a:t>Second level</a:t>
+            </a:r>
+          </a:p>
+          <a:p>
+            <a:pPr lvl="2"/>
+            <a:r>
+              <a:rPr lang="en-US"/>
+              <a:t>Third level</a:t>
+            </a:r>
+          </a:p>
+          <a:p>
+            <a:pPr lvl="3"/>
+            <a:r>
+              <a:rPr lang="en-US"/>
+              <a:t>Fourth level</a:t>
+            </a:r>
+          </a:p>
+          <a:p>
+            <a:pPr lvl="4"/>
+            <a:r>
+              <a:rPr lang="en-US"/>
+              <a:t>Fifth level</a:t>
+            </a:r>
+          </a:p>
+        </p:txBody>
+      </p:sp>
+      <p:sp>
+        <p:nvSpPr>
+          <p:cNvPr id="6" name="Footer Placeholder 5"/>
+          <p:cNvSpPr>
+            <a:spLocks noGrp="1"/>
+          </p:cNvSpPr>
+          <p:nvPr>
+            <p:ph type="ftr" sz="quarter" idx="4"/>
+          </p:nvPr>
+        </p:nvSpPr>
+        <p:spPr>
+          <a:xfrm>
+            <a:off x="0" y="8685213"/>
+            <a:ext cx="2971800" cy="458787"/>
+          </a:xfrm>
+          <a:prstGeom prst="rect">
+            <a:avLst/>
+          </a:prstGeom>
+        </p:spPr>
+        <p:txBody>
+          <a:bodyPr vert="horz" lIns="91440" tIns="45720" rIns="91440" bIns="45720" rtlCol="0" anchor="b"/>
+          <a:lstStyle>
+            <a:lvl1pPr algn="l">
+              <a:defRPr sz="1200"/>
+            </a:lvl1pPr>
+          </a:lstStyle>
+          <a:p>
+            <a:endParaRPr lang="en-US"/>
+          </a:p>
+        </p:txBody>
+      </p:sp>
+      <p:sp>
+        <p:nvSpPr>
+          <p:cNvPr id="7" name="Slide Number Placeholder 6"/>
+          <p:cNvSpPr>
+            <a:spLocks noGrp="1"/>
+          </p:cNvSpPr>
+          <p:nvPr>
+            <p:ph type="sldNum" sz="quarter" idx="5"/>
+          </p:nvPr>
+        </p:nvSpPr>
+        <p:spPr>
+          <a:xfrm>
+            <a:off x="3884613" y="8685213"/>
+            <a:ext cx="2971800" cy="458787"/>
+          </a:xfrm>
+          <a:prstGeom prst="rect">
+            <a:avLst/>
+          </a:prstGeom>
+        </p:spPr>
+        <p:txBody>
+          <a:bodyPr vert="horz" lIns="91440" tIns="45720" rIns="91440" bIns="45720" rtlCol="0" anchor="b"/>
+          <a:lstStyle>
+            <a:lvl1pPr algn="r">
+              <a:defRPr sz="1200"/>
+            </a:lvl1pPr>
+          </a:lstStyle>
+          <a:p>
+            <a:fld id="{CE5E9CC1-C706-0F49-92D6-E571CC5EEA8F}" type="slidenum">
+              <a:rPr lang="en-US"/>
+              <a:t>‹#›</a:t>
+            </a:fld>
+            <a:endParaRPr lang="en-US"/>
+          </a:p>
+        </p:txBody>
+      </p:sp>
     </p:spTree>
     <p:extLst>
       <p:ext uri="{BB962C8B-B14F-4D97-AF65-F5344CB8AC3E}">
-        <p14:creationId xmlns:p14="http://schemas.microsoft.com/office/powerpoint/2010/main" val="2299707693"/>
+        <p14:creationId xmlns:p14="http://schemas.microsoft.com/office/powerpoint/2010/main" val="1024086991"/>
       </p:ext>
     </p:extLst>
   </p:cSld>
@@ -283,6 +504,10 @@
           <a:bodyPr/>
           <a:lstStyle/>
           <a:p>
+            <a:r>
+              <a:rPr lang="en-US" dirty="0"/>
+              <a:t/>
+            </a:r>
             <a:endParaRPr lang="en-US" dirty="0"/>
           </a:p>
         </p:txBody>
@@ -367,6 +592,10 @@
           <a:bodyPr/>
           <a:lstStyle/>
           <a:p>
+            <a:r>
+              <a:rPr lang="en-US" dirty="0"/>
+              <a:t/>
+            </a:r>
             <a:endParaRPr lang="en-US" dirty="0"/>
           </a:p>
         </p:txBody>
@@ -451,6 +680,10 @@
           <a:bodyPr/>
           <a:lstStyle/>
           <a:p>
+            <a:r>
+              <a:rPr lang="en-US" dirty="0"/>
+              <a:t/>
+            </a:r>
             <a:endParaRPr lang="en-US" dirty="0"/>
           </a:p>
         </p:txBody>
@@ -524,11 +757,6 @@
 <file path=ppt/slideMasters/slideMaster1.xml><?xml version="1.0" encoding="utf-8"?>
 <p:sldMaster xmlns:a="http://schemas.openxmlformats.org/drawingml/2006/main" xmlns:r="http://schemas.openxmlformats.org/officeDocument/2006/relationships" xmlns:p="http://schemas.openxmlformats.org/presentationml/2006/main">
   <p:cSld>
-    <p:bg>
-      <p:bgRef idx="1001">
-        <a:schemeClr val="bg1"/>
-      </p:bgRef>
-    </p:bg>
     <p:spTree>
       <p:nvGrpSpPr>
         <p:cNvPr id="1" name=""/>
@@ -811,7 +1039,6 @@
         <a:solidFill>
           <a:srgbClr val="10263F"/>
         </a:solidFill>
-        <a:effectLst/>
       </p:bgPr>
     </p:bg>
     <p:spTree>
@@ -874,7 +1101,7 @@
           <a:bodyPr wrap="square" rtlCol="0" anchor="ctr"/>
           <a:lstStyle/>
           <a:p>
-            <a:pPr marL="0" indent="0" algn="ctr">
+            <a:pPr algn="ctr" indent="0" marL="0">
               <a:buNone/>
             </a:pPr>
             <a:r>
@@ -913,11 +1140,11 @@
           <a:bodyPr wrap="square" rtlCol="0" anchor="ctr"/>
           <a:lstStyle/>
           <a:p>
-            <a:pPr marL="0" indent="0">
+            <a:pPr indent="0" marL="0">
               <a:buNone/>
             </a:pPr>
             <a:r>
-              <a:rPr lang="en-US" sz="4000" b="1" kern="0" spc="50" dirty="0">
+              <a:rPr lang="en-US" sz="4000" b="1" spc="50" kern="0" dirty="0">
                 <a:solidFill>
                   <a:srgbClr val="FFFFFF"/>
                 </a:solidFill>
@@ -952,11 +1179,11 @@
           <a:bodyPr wrap="square" rtlCol="0" anchor="ctr"/>
           <a:lstStyle/>
           <a:p>
-            <a:pPr marL="0" indent="0">
+            <a:pPr indent="0" marL="0">
               <a:buNone/>
             </a:pPr>
             <a:r>
-              <a:rPr lang="en-US" sz="4000" b="1" kern="0" spc="50" dirty="0">
+              <a:rPr lang="en-US" sz="4000" b="1" spc="50" kern="0" dirty="0">
                 <a:solidFill>
                   <a:srgbClr val="7C5CFC"/>
                 </a:solidFill>
@@ -991,7 +1218,7 @@
           <a:bodyPr wrap="square" rtlCol="0" anchor="ctr"/>
           <a:lstStyle/>
           <a:p>
-            <a:pPr marL="0" indent="0">
+            <a:pPr indent="0" marL="0">
               <a:buNone/>
             </a:pPr>
             <a:r>
@@ -1030,7 +1257,7 @@
           <a:bodyPr wrap="square" rtlCol="0" anchor="ctr"/>
           <a:lstStyle/>
           <a:p>
-            <a:pPr marL="0" indent="0">
+            <a:pPr indent="0" marL="0">
               <a:buNone/>
             </a:pPr>
             <a:r>
@@ -1069,7 +1296,7 @@
           <a:bodyPr wrap="square" rtlCol="0" anchor="ctr"/>
           <a:lstStyle/>
           <a:p>
-            <a:pPr marL="0" indent="0">
+            <a:pPr indent="0" marL="0">
               <a:buNone/>
             </a:pPr>
             <a:r>
@@ -1108,7 +1335,7 @@
           <a:bodyPr wrap="square" rtlCol="0" anchor="t"/>
           <a:lstStyle/>
           <a:p>
-            <a:pPr marL="0" indent="0">
+            <a:pPr indent="0" marL="0">
               <a:buNone/>
             </a:pPr>
             <a:r>
@@ -1147,7 +1374,7 @@
           <a:bodyPr wrap="square" rtlCol="0" anchor="ctr"/>
           <a:lstStyle/>
           <a:p>
-            <a:pPr marL="0" indent="0">
+            <a:pPr indent="0" marL="0">
               <a:buNone/>
             </a:pPr>
             <a:r>
@@ -1186,7 +1413,7 @@
           <a:bodyPr wrap="square" rtlCol="0" anchor="t"/>
           <a:lstStyle/>
           <a:p>
-            <a:pPr marL="0" indent="0">
+            <a:pPr indent="0" marL="0">
               <a:buNone/>
             </a:pPr>
             <a:r>
@@ -1225,7 +1452,7 @@
           <a:bodyPr wrap="square" rtlCol="0" anchor="ctr"/>
           <a:lstStyle/>
           <a:p>
-            <a:pPr marL="0" indent="0">
+            <a:pPr indent="0" marL="0">
               <a:buNone/>
             </a:pPr>
             <a:r>
@@ -1264,7 +1491,7 @@
           <a:bodyPr wrap="square" rtlCol="0" anchor="ctr"/>
           <a:lstStyle/>
           <a:p>
-            <a:pPr marL="0" indent="0" algn="r">
+            <a:pPr algn="r" indent="0" marL="0">
               <a:buNone/>
             </a:pPr>
             <a:r>
@@ -1298,7 +1525,6 @@
         <a:solidFill>
           <a:srgbClr val="10263F"/>
         </a:solidFill>
-        <a:effectLst/>
       </p:bgPr>
     </p:bg>
     <p:spTree>
@@ -1336,7 +1562,7 @@
           <a:bodyPr wrap="square" rtlCol="0" anchor="ctr"/>
           <a:lstStyle/>
           <a:p>
-            <a:pPr marL="0" indent="0">
+            <a:pPr indent="0" marL="0">
               <a:buNone/>
             </a:pPr>
             <a:r>
@@ -1375,7 +1601,7 @@
           <a:bodyPr wrap="square" rtlCol="0" anchor="ctr"/>
           <a:lstStyle/>
           <a:p>
-            <a:pPr marL="0" indent="0">
+            <a:pPr indent="0" marL="0">
               <a:buNone/>
             </a:pPr>
             <a:r>
@@ -1436,11 +1662,11 @@
           <a:bodyPr wrap="square" rtlCol="0" anchor="ctr"/>
           <a:lstStyle/>
           <a:p>
-            <a:pPr marL="0" indent="0">
+            <a:pPr indent="0" marL="0">
               <a:buNone/>
             </a:pPr>
             <a:r>
-              <a:rPr lang="en-US" sz="1100" b="1" kern="0" spc="100" dirty="0">
+              <a:rPr lang="en-US" sz="1100" b="1" spc="100" kern="0" dirty="0">
                 <a:solidFill>
                   <a:srgbClr val="7C5CFC"/>
                 </a:solidFill>
@@ -1475,7 +1701,7 @@
           <a:bodyPr wrap="square" rtlCol="0" anchor="t"/>
           <a:lstStyle/>
           <a:p>
-            <a:pPr marL="0" indent="0">
+            <a:pPr indent="0" marL="0">
               <a:buNone/>
             </a:pPr>
             <a:r>
@@ -1536,11 +1762,11 @@
           <a:bodyPr wrap="square" rtlCol="0" anchor="ctr"/>
           <a:lstStyle/>
           <a:p>
-            <a:pPr marL="0" indent="0">
+            <a:pPr indent="0" marL="0">
               <a:buNone/>
             </a:pPr>
             <a:r>
-              <a:rPr lang="en-US" sz="1100" b="1" kern="0" spc="100" dirty="0">
+              <a:rPr lang="en-US" sz="1100" b="1" spc="100" kern="0" dirty="0">
                 <a:solidFill>
                   <a:srgbClr val="7C5CFC"/>
                 </a:solidFill>
@@ -1575,7 +1801,7 @@
           <a:bodyPr wrap="square" rtlCol="0" anchor="t"/>
           <a:lstStyle/>
           <a:p>
-            <a:pPr marL="0" indent="0">
+            <a:pPr indent="0" marL="0">
               <a:buNone/>
             </a:pPr>
             <a:r>
@@ -1614,7 +1840,7 @@
           <a:bodyPr wrap="square" rtlCol="0" anchor="ctr"/>
           <a:lstStyle/>
           <a:p>
-            <a:pPr marL="0" indent="0">
+            <a:pPr indent="0" marL="0">
               <a:buNone/>
             </a:pPr>
             <a:r>
@@ -1656,14 +1882,14 @@
       </p:sp>
       <p:pic>
         <p:nvPicPr>
-          <p:cNvPr id="12" name="Image 0" descr="/private/tmp/claude-501/-Users-marius-ayoro/7f816881-553d-470c-99ea-a412f0e083b6/scratchpad/cas_usage_pii/pipeline_schema.png"/>
+          <p:cNvPr id="12" name="Image 0" descr="/private/tmp/claude-501/-Users-marius-ayoro/7f816881-553d-470c-99ea-a412f0e083b6/scratchpad/cas_usage_pii/pipeline_schema.png">    </p:cNvPr>
           <p:cNvPicPr>
             <a:picLocks noChangeAspect="1"/>
           </p:cNvPicPr>
           <p:nvPr/>
         </p:nvPicPr>
         <p:blipFill>
-          <a:blip r:embed="rId3"/>
+          <a:blip r:embed="rId1"/>
           <a:stretch>
             <a:fillRect/>
           </a:stretch>
@@ -1699,7 +1925,7 @@
           <a:bodyPr wrap="square" rtlCol="0" anchor="ctr"/>
           <a:lstStyle/>
           <a:p>
-            <a:pPr marL="0" indent="0">
+            <a:pPr indent="0" marL="0">
               <a:buNone/>
             </a:pPr>
             <a:r>
@@ -1738,7 +1964,7 @@
           <a:bodyPr wrap="square" rtlCol="0" anchor="ctr"/>
           <a:lstStyle/>
           <a:p>
-            <a:pPr marL="0" indent="0" algn="r">
+            <a:pPr algn="r" indent="0" marL="0">
               <a:buNone/>
             </a:pPr>
             <a:r>
@@ -1772,7 +1998,6 @@
         <a:solidFill>
           <a:srgbClr val="10263F"/>
         </a:solidFill>
-        <a:effectLst/>
       </p:bgPr>
     </p:bg>
     <p:spTree>
@@ -1810,7 +2035,7 @@
           <a:bodyPr wrap="square" rtlCol="0" anchor="ctr"/>
           <a:lstStyle/>
           <a:p>
-            <a:pPr marL="0" indent="0">
+            <a:pPr indent="0" marL="0">
               <a:buNone/>
             </a:pPr>
             <a:r>
@@ -1849,7 +2074,7 @@
           <a:bodyPr wrap="square" rtlCol="0" anchor="ctr"/>
           <a:lstStyle/>
           <a:p>
-            <a:pPr marL="0" indent="0">
+            <a:pPr indent="0" marL="0">
               <a:buNone/>
             </a:pPr>
             <a:r>
@@ -1910,7 +2135,7 @@
           <a:bodyPr wrap="square" rtlCol="0" anchor="ctr"/>
           <a:lstStyle/>
           <a:p>
-            <a:pPr marL="0" indent="0" algn="ctr">
+            <a:pPr algn="ctr" indent="0" marL="0">
               <a:buNone/>
             </a:pPr>
             <a:r>
@@ -1949,7 +2174,7 @@
           <a:bodyPr wrap="square" rtlCol="0" anchor="ctr"/>
           <a:lstStyle/>
           <a:p>
-            <a:pPr marL="0" indent="0" algn="ctr">
+            <a:pPr algn="ctr" indent="0" marL="0">
               <a:buNone/>
             </a:pPr>
             <a:r>
@@ -2010,7 +2235,7 @@
           <a:bodyPr wrap="square" rtlCol="0" anchor="ctr"/>
           <a:lstStyle/>
           <a:p>
-            <a:pPr marL="0" indent="0" algn="ctr">
+            <a:pPr algn="ctr" indent="0" marL="0">
               <a:buNone/>
             </a:pPr>
             <a:r>
@@ -2049,7 +2274,7 @@
           <a:bodyPr wrap="square" rtlCol="0" anchor="ctr"/>
           <a:lstStyle/>
           <a:p>
-            <a:pPr marL="0" indent="0" algn="ctr">
+            <a:pPr algn="ctr" indent="0" marL="0">
               <a:buNone/>
             </a:pPr>
             <a:r>
@@ -2110,7 +2335,7 @@
           <a:bodyPr wrap="square" rtlCol="0" anchor="ctr"/>
           <a:lstStyle/>
           <a:p>
-            <a:pPr marL="0" indent="0" algn="ctr">
+            <a:pPr algn="ctr" indent="0" marL="0">
               <a:buNone/>
             </a:pPr>
             <a:r>
@@ -2149,7 +2374,7 @@
           <a:bodyPr wrap="square" rtlCol="0" anchor="ctr"/>
           <a:lstStyle/>
           <a:p>
-            <a:pPr marL="0" indent="0" algn="ctr">
+            <a:pPr algn="ctr" indent="0" marL="0">
               <a:buNone/>
             </a:pPr>
             <a:r>
@@ -2210,7 +2435,7 @@
           <a:bodyPr wrap="square" rtlCol="0" anchor="ctr"/>
           <a:lstStyle/>
           <a:p>
-            <a:pPr marL="0" indent="0" algn="ctr">
+            <a:pPr algn="ctr" indent="0" marL="0">
               <a:buNone/>
             </a:pPr>
             <a:r>
@@ -2249,7 +2474,7 @@
           <a:bodyPr wrap="square" rtlCol="0" anchor="ctr"/>
           <a:lstStyle/>
           <a:p>
-            <a:pPr marL="0" indent="0" algn="ctr">
+            <a:pPr algn="ctr" indent="0" marL="0">
               <a:buNone/>
             </a:pPr>
             <a:r>
@@ -2288,7 +2513,7 @@
           <a:bodyPr wrap="square" rtlCol="0" anchor="ctr"/>
           <a:lstStyle/>
           <a:p>
-            <a:pPr marL="0" indent="0">
+            <a:pPr indent="0" marL="0">
               <a:buNone/>
             </a:pPr>
             <a:r>
@@ -2347,7 +2572,7 @@
           <a:bodyPr wrap="square" rtlCol="0" anchor="t"/>
           <a:lstStyle/>
           <a:p>
-            <a:pPr marL="0" indent="0">
+            <a:pPr indent="0" marL="0">
               <a:buNone/>
             </a:pPr>
             <a:r>
@@ -2406,7 +2631,7 @@
           <a:bodyPr wrap="square" rtlCol="0" anchor="t"/>
           <a:lstStyle/>
           <a:p>
-            <a:pPr marL="0" indent="0">
+            <a:pPr indent="0" marL="0">
               <a:buNone/>
             </a:pPr>
             <a:r>
@@ -2465,7 +2690,7 @@
           <a:bodyPr wrap="square" rtlCol="0" anchor="t"/>
           <a:lstStyle/>
           <a:p>
-            <a:pPr marL="0" indent="0">
+            <a:pPr indent="0" marL="0">
               <a:buNone/>
             </a:pPr>
             <a:r>
@@ -2524,7 +2749,7 @@
           <a:bodyPr wrap="square" rtlCol="0" anchor="t"/>
           <a:lstStyle/>
           <a:p>
-            <a:pPr marL="0" indent="0">
+            <a:pPr indent="0" marL="0">
               <a:buNone/>
             </a:pPr>
             <a:r>
@@ -2585,7 +2810,7 @@
           <a:bodyPr wrap="square" rtlCol="0" anchor="ctr"/>
           <a:lstStyle/>
           <a:p>
-            <a:pPr marL="0" indent="0">
+            <a:pPr indent="0" marL="0">
               <a:buNone/>
             </a:pPr>
             <a:r>
@@ -2624,7 +2849,7 @@
           <a:bodyPr wrap="square" rtlCol="0" anchor="ctr"/>
           <a:lstStyle/>
           <a:p>
-            <a:pPr marL="0" indent="0">
+            <a:pPr indent="0" marL="0">
               <a:buNone/>
             </a:pPr>
             <a:r>
@@ -2636,71 +2861,686 @@
                 <a:ea typeface="Calibri" pitchFamily="34" charset="-122"/>
                 <a:cs typeface="Calibri" pitchFamily="34" charset="-120"/>
               </a:rPr>
-              <a:t>Prochaine étape : formation « L'IA au Bureau » — 28-29 juillet 2026, </a:t>
-            </a:r>
-            <a:r>
-              <a:rPr lang="en-US" sz="1100" dirty="0" err="1">
-                <a:solidFill>
-                  <a:srgbClr val="EDE9FF"/>
+              <a:t>Prochaine étape : formation « L'IA au Bureau » — 28-29 juillet 2026, Riviera 3, Abidjan</a:t>
+            </a:r>
+            <a:endParaRPr lang="en-US" sz="1100" dirty="0"/>
+          </a:p>
+        </p:txBody>
+      </p:sp>
+      <p:sp>
+        <p:nvSpPr>
+          <p:cNvPr id="28" name="Text 26"/>
+          <p:cNvSpPr/>
+          <p:nvPr/>
+        </p:nvSpPr>
+        <p:spPr>
+          <a:xfrm>
+            <a:off x="457200" y="6473952"/>
+            <a:ext cx="7315200" cy="274320"/>
+          </a:xfrm>
+          <a:prstGeom prst="rect">
+            <a:avLst/>
+          </a:prstGeom>
+          <a:noFill/>
+          <a:ln/>
+        </p:spPr>
+        <p:txBody>
+          <a:bodyPr wrap="square" rtlCol="0" anchor="ctr"/>
+          <a:lstStyle/>
+          <a:p>
+            <a:pPr indent="0" marL="0">
+              <a:buNone/>
+            </a:pPr>
+            <a:r>
+              <a:rPr lang="en-US" sz="900" dirty="0">
+                <a:solidFill>
+                  <a:srgbClr val="8A93AC"/>
                 </a:solidFill>
                 <a:latin typeface="Calibri" pitchFamily="34" charset="0"/>
                 <a:ea typeface="Calibri" pitchFamily="34" charset="-122"/>
                 <a:cs typeface="Calibri" pitchFamily="34" charset="-120"/>
               </a:rPr>
-              <a:t>ou</a:t>
-            </a:r>
-            <a:r>
-              <a:rPr lang="en-US" sz="1100" dirty="0">
-                <a:solidFill>
-                  <a:srgbClr val="EDE9FF"/>
+              <a:t>contact@transferai.ci  •  www.transferai.ci</a:t>
+            </a:r>
+            <a:endParaRPr lang="en-US" sz="900" dirty="0"/>
+          </a:p>
+        </p:txBody>
+      </p:sp>
+      <p:sp>
+        <p:nvSpPr>
+          <p:cNvPr id="29" name="Text 27"/>
+          <p:cNvSpPr/>
+          <p:nvPr/>
+        </p:nvSpPr>
+        <p:spPr>
+          <a:xfrm>
+            <a:off x="8503920" y="6473952"/>
+            <a:ext cx="3200400" cy="274320"/>
+          </a:xfrm>
+          <a:prstGeom prst="rect">
+            <a:avLst/>
+          </a:prstGeom>
+          <a:noFill/>
+          <a:ln/>
+        </p:spPr>
+        <p:txBody>
+          <a:bodyPr wrap="square" rtlCol="0" anchor="ctr"/>
+          <a:lstStyle/>
+          <a:p>
+            <a:pPr algn="r" indent="0" marL="0">
+              <a:buNone/>
+            </a:pPr>
+            <a:r>
+              <a:rPr lang="en-US" sz="900" dirty="0">
+                <a:solidFill>
+                  <a:srgbClr val="8A93AC"/>
                 </a:solidFill>
                 <a:latin typeface="Calibri" pitchFamily="34" charset="0"/>
                 <a:ea typeface="Calibri" pitchFamily="34" charset="-122"/>
                 <a:cs typeface="Calibri" pitchFamily="34" charset="-120"/>
               </a:rPr>
-              <a:t> 10-11 </a:t>
-            </a:r>
-            <a:r>
-              <a:rPr lang="en-US" sz="1100" dirty="0" err="1">
-                <a:solidFill>
-                  <a:srgbClr val="EDE9FF"/>
-                </a:solidFill>
-                <a:latin typeface="Calibri" pitchFamily="34" charset="0"/>
-                <a:ea typeface="Calibri" pitchFamily="34" charset="-122"/>
-                <a:cs typeface="Calibri" pitchFamily="34" charset="-120"/>
-              </a:rPr>
-              <a:t>aout</a:t>
-            </a:r>
-            <a:r>
-              <a:rPr lang="en-US" sz="1100">
-                <a:solidFill>
-                  <a:srgbClr val="EDE9FF"/>
-                </a:solidFill>
-                <a:latin typeface="Calibri" pitchFamily="34" charset="0"/>
-                <a:ea typeface="Calibri" pitchFamily="34" charset="-122"/>
-                <a:cs typeface="Calibri" pitchFamily="34" charset="-120"/>
-              </a:rPr>
-              <a:t> 2026 </a:t>
-            </a:r>
-            <a:r>
-              <a:rPr lang="en-US" sz="1100" dirty="0">
-                <a:solidFill>
-                  <a:srgbClr val="EDE9FF"/>
-                </a:solidFill>
-                <a:latin typeface="Calibri" pitchFamily="34" charset="0"/>
-                <a:ea typeface="Calibri" pitchFamily="34" charset="-122"/>
-                <a:cs typeface="Calibri" pitchFamily="34" charset="-120"/>
-              </a:rPr>
-              <a:t>Riviera 3, Abidjan</a:t>
-            </a:r>
-            <a:endParaRPr lang="en-US" sz="1100" dirty="0"/>
-          </a:p>
-        </p:txBody>
-      </p:sp>
-      <p:sp>
-        <p:nvSpPr>
-          <p:cNvPr id="28" name="Text 26"/>
-          <p:cNvSpPr/>
+              <a:t>18 juillet 2026</a:t>
+            </a:r>
+            <a:endParaRPr lang="en-US" sz="900" dirty="0"/>
+          </a:p>
+        </p:txBody>
+      </p:sp>
+    </p:spTree>
+  </p:cSld>
+  <p:clrMapOvr>
+    <a:masterClrMapping/>
+  </p:clrMapOvr>
+</p:sld>
+</file>
+
+<file path=ppt/slides/slide4.xml><?xml version="1.0" encoding="utf-8"?>
+<p:sld xmlns:a="http://schemas.openxmlformats.org/drawingml/2006/main" xmlns:p="http://schemas.openxmlformats.org/presentationml/2006/main" xmlns:r="http://schemas.openxmlformats.org/officeDocument/2006/relationships">
+  <p:cSld>
+    <p:bg>
+      <p:bgPr>
+        <a:solidFill>
+          <a:srgbClr val="10263F"/>
+        </a:solidFill>
+        <a:effectLst/>
+      </p:bgPr>
+    </p:bg>
+    <p:spTree>
+      <p:nvGrpSpPr>
+        <p:cNvPr id="1" name=""/>
+        <p:cNvGrpSpPr/>
+        <p:nvPr/>
+      </p:nvGrpSpPr>
+      <p:grpSpPr/>
+      <p:sp>
+        <p:nvSpPr>
+          <p:cNvPr id="2" name="TextBox 1"/>
+          <p:cNvSpPr txBox="1"/>
+          <p:nvPr/>
+        </p:nvSpPr>
+        <p:spPr>
+          <a:xfrm>
+            <a:off x="548640" y="457200"/>
+            <a:ext cx="10515600" cy="502920"/>
+          </a:xfrm>
+          <a:prstGeom prst="rect">
+            <a:avLst/>
+          </a:prstGeom>
+          <a:noFill/>
+        </p:spPr>
+        <p:txBody>
+          <a:bodyPr wrap="square" lIns="0" rIns="0" tIns="0" bIns="0">
+            <a:spAutoFit/>
+          </a:bodyPr>
+          <a:lstStyle/>
+          <a:p>
+            <a:pPr algn="l"/>
+            <a:r>
+              <a:rPr sz="2600" b="1">
+                <a:solidFill>
+                  <a:srgbClr val="FFFFFF"/>
+                </a:solidFill>
+                <a:latin typeface="Calibri"/>
+              </a:rPr>
+              <a:t>Bénéfices &amp; retour sur investissement</a:t>
+            </a:r>
+          </a:p>
+        </p:txBody>
+      </p:sp>
+      <p:sp>
+        <p:nvSpPr>
+          <p:cNvPr id="3" name="TextBox 2"/>
+          <p:cNvSpPr txBox="1"/>
+          <p:nvPr/>
+        </p:nvSpPr>
+        <p:spPr>
+          <a:xfrm>
+            <a:off x="548640" y="960120"/>
+            <a:ext cx="10058400" cy="365760"/>
+          </a:xfrm>
+          <a:prstGeom prst="rect">
+            <a:avLst/>
+          </a:prstGeom>
+          <a:noFill/>
+        </p:spPr>
+        <p:txBody>
+          <a:bodyPr wrap="square" lIns="0" rIns="0" tIns="0" bIns="0">
+            <a:spAutoFit/>
+          </a:bodyPr>
+          <a:lstStyle/>
+          <a:p>
+            <a:pPr algn="l"/>
+            <a:r>
+              <a:rPr sz="1300" b="0">
+                <a:solidFill>
+                  <a:srgbClr val="B7C0D8"/>
+                </a:solidFill>
+                <a:latin typeface="Calibri"/>
+              </a:rPr>
+              <a:t>Ce que ce pipeline change concrètement pour la secrétaire et le manager qui traitent un courrier sensible.</a:t>
+            </a:r>
+          </a:p>
+        </p:txBody>
+      </p:sp>
+      <p:sp>
+        <p:nvSpPr>
+          <p:cNvPr id="4" name="Oval 3"/>
+          <p:cNvSpPr/>
+          <p:nvPr/>
+        </p:nvSpPr>
+        <p:spPr>
+          <a:xfrm>
+            <a:off x="594360" y="1417320"/>
+            <a:ext cx="594360" cy="594360"/>
+          </a:xfrm>
+          <a:prstGeom prst="ellipse">
+            <a:avLst/>
+          </a:prstGeom>
+          <a:solidFill>
+            <a:srgbClr val="2A2455"/>
+          </a:solidFill>
+          <a:ln w="12700">
+            <a:solidFill>
+              <a:srgbClr val="7C5CFC"/>
+            </a:solidFill>
+          </a:ln>
+          <a:effectLst/>
+        </p:spPr>
+        <p:style>
+          <a:lnRef idx="1">
+            <a:schemeClr val="accent1"/>
+          </a:lnRef>
+          <a:fillRef idx="3">
+            <a:schemeClr val="accent1"/>
+          </a:fillRef>
+          <a:effectRef idx="2">
+            <a:schemeClr val="accent1"/>
+          </a:effectRef>
+          <a:fontRef idx="minor">
+            <a:schemeClr val="lt1"/>
+          </a:fontRef>
+        </p:style>
+        <p:txBody>
+          <a:bodyPr rtlCol="0" anchor="ctr" wrap="none" lIns="0" rIns="0" tIns="0" bIns="0"/>
+          <a:lstStyle/>
+          <a:p>
+            <a:pPr algn="ctr"/>
+            <a:r>
+              <a:rPr sz="2000" b="1">
+                <a:solidFill>
+                  <a:srgbClr val="7C5CFC"/>
+                </a:solidFill>
+              </a:rPr>
+              <a:t>✍️</a:t>
+            </a:r>
+          </a:p>
+        </p:txBody>
+      </p:sp>
+      <p:sp>
+        <p:nvSpPr>
+          <p:cNvPr id="5" name="TextBox 4"/>
+          <p:cNvSpPr txBox="1"/>
+          <p:nvPr/>
+        </p:nvSpPr>
+        <p:spPr>
+          <a:xfrm>
+            <a:off x="548640" y="2130552"/>
+            <a:ext cx="3520440" cy="457200"/>
+          </a:xfrm>
+          <a:prstGeom prst="rect">
+            <a:avLst/>
+          </a:prstGeom>
+          <a:noFill/>
+        </p:spPr>
+        <p:txBody>
+          <a:bodyPr wrap="square" lIns="0" rIns="0" tIns="0" bIns="0">
+            <a:spAutoFit/>
+          </a:bodyPr>
+          <a:lstStyle/>
+          <a:p>
+            <a:pPr algn="l"/>
+            <a:r>
+              <a:rPr sz="1700" b="1">
+                <a:solidFill>
+                  <a:srgbClr val="FFFFFF"/>
+                </a:solidFill>
+                <a:latin typeface="Calibri"/>
+              </a:rPr>
+              <a:t>Rédaction accélérée</a:t>
+            </a:r>
+          </a:p>
+        </p:txBody>
+      </p:sp>
+      <p:sp>
+        <p:nvSpPr>
+          <p:cNvPr id="6" name="TextBox 5"/>
+          <p:cNvSpPr txBox="1"/>
+          <p:nvPr/>
+        </p:nvSpPr>
+        <p:spPr>
+          <a:xfrm>
+            <a:off x="548640" y="2587752"/>
+            <a:ext cx="3520440" cy="1097280"/>
+          </a:xfrm>
+          <a:prstGeom prst="rect">
+            <a:avLst/>
+          </a:prstGeom>
+          <a:noFill/>
+        </p:spPr>
+        <p:txBody>
+          <a:bodyPr wrap="square" lIns="0" rIns="0" tIns="0" bIns="0">
+            <a:spAutoFit/>
+          </a:bodyPr>
+          <a:lstStyle/>
+          <a:p>
+            <a:pPr algn="l"/>
+            <a:r>
+              <a:rPr sz="1250" b="0">
+                <a:solidFill>
+                  <a:srgbClr val="B7C0D8"/>
+                </a:solidFill>
+                <a:latin typeface="Calibri"/>
+              </a:rPr>
+              <a:t>Le courrier est généré à partir des instructions du dossier — la secrétaire relit et corrige au lieu de rédiger depuis une page blanche.</a:t>
+            </a:r>
+          </a:p>
+        </p:txBody>
+      </p:sp>
+      <p:sp>
+        <p:nvSpPr>
+          <p:cNvPr id="7" name="Oval 6"/>
+          <p:cNvSpPr/>
+          <p:nvPr/>
+        </p:nvSpPr>
+        <p:spPr>
+          <a:xfrm>
+            <a:off x="4370832" y="1417320"/>
+            <a:ext cx="594360" cy="594360"/>
+          </a:xfrm>
+          <a:prstGeom prst="ellipse">
+            <a:avLst/>
+          </a:prstGeom>
+          <a:solidFill>
+            <a:srgbClr val="2A2455"/>
+          </a:solidFill>
+          <a:ln w="12700">
+            <a:solidFill>
+              <a:srgbClr val="7C5CFC"/>
+            </a:solidFill>
+          </a:ln>
+          <a:effectLst/>
+        </p:spPr>
+        <p:style>
+          <a:lnRef idx="1">
+            <a:schemeClr val="accent1"/>
+          </a:lnRef>
+          <a:fillRef idx="3">
+            <a:schemeClr val="accent1"/>
+          </a:fillRef>
+          <a:effectRef idx="2">
+            <a:schemeClr val="accent1"/>
+          </a:effectRef>
+          <a:fontRef idx="minor">
+            <a:schemeClr val="lt1"/>
+          </a:fontRef>
+        </p:style>
+        <p:txBody>
+          <a:bodyPr rtlCol="0" anchor="ctr" wrap="none" lIns="0" rIns="0" tIns="0" bIns="0"/>
+          <a:lstStyle/>
+          <a:p>
+            <a:pPr algn="ctr"/>
+            <a:r>
+              <a:rPr sz="2000" b="1">
+                <a:solidFill>
+                  <a:srgbClr val="7C5CFC"/>
+                </a:solidFill>
+              </a:rPr>
+              <a:t>🔁</a:t>
+            </a:r>
+          </a:p>
+        </p:txBody>
+      </p:sp>
+      <p:sp>
+        <p:nvSpPr>
+          <p:cNvPr id="8" name="TextBox 7"/>
+          <p:cNvSpPr txBox="1"/>
+          <p:nvPr/>
+        </p:nvSpPr>
+        <p:spPr>
+          <a:xfrm>
+            <a:off x="4325112" y="2130552"/>
+            <a:ext cx="3520440" cy="457200"/>
+          </a:xfrm>
+          <a:prstGeom prst="rect">
+            <a:avLst/>
+          </a:prstGeom>
+          <a:noFill/>
+        </p:spPr>
+        <p:txBody>
+          <a:bodyPr wrap="square" lIns="0" rIns="0" tIns="0" bIns="0">
+            <a:spAutoFit/>
+          </a:bodyPr>
+          <a:lstStyle/>
+          <a:p>
+            <a:pPr algn="l"/>
+            <a:r>
+              <a:rPr sz="1700" b="1">
+                <a:solidFill>
+                  <a:srgbClr val="FFFFFF"/>
+                </a:solidFill>
+                <a:latin typeface="Calibri"/>
+              </a:rPr>
+              <a:t>Moins d'allers-retours</a:t>
+            </a:r>
+          </a:p>
+        </p:txBody>
+      </p:sp>
+      <p:sp>
+        <p:nvSpPr>
+          <p:cNvPr id="9" name="TextBox 8"/>
+          <p:cNvSpPr txBox="1"/>
+          <p:nvPr/>
+        </p:nvSpPr>
+        <p:spPr>
+          <a:xfrm>
+            <a:off x="4325112" y="2587752"/>
+            <a:ext cx="3520440" cy="1097280"/>
+          </a:xfrm>
+          <a:prstGeom prst="rect">
+            <a:avLst/>
+          </a:prstGeom>
+          <a:noFill/>
+        </p:spPr>
+        <p:txBody>
+          <a:bodyPr wrap="square" lIns="0" rIns="0" tIns="0" bIns="0">
+            <a:spAutoFit/>
+          </a:bodyPr>
+          <a:lstStyle/>
+          <a:p>
+            <a:pPr algn="l"/>
+            <a:r>
+              <a:rPr sz="1250" b="0">
+                <a:solidFill>
+                  <a:srgbClr val="B7C0D8"/>
+                </a:solidFill>
+                <a:latin typeface="Calibri"/>
+              </a:rPr>
+              <a:t>Un seul point de validation humaine (le manager) avant envoi, avec correction directe si besoin — pas une chaîne d'emails à rallonge.</a:t>
+            </a:r>
+          </a:p>
+        </p:txBody>
+      </p:sp>
+      <p:sp>
+        <p:nvSpPr>
+          <p:cNvPr id="10" name="Oval 9"/>
+          <p:cNvSpPr/>
+          <p:nvPr/>
+        </p:nvSpPr>
+        <p:spPr>
+          <a:xfrm>
+            <a:off x="8147304" y="1417320"/>
+            <a:ext cx="594360" cy="594360"/>
+          </a:xfrm>
+          <a:prstGeom prst="ellipse">
+            <a:avLst/>
+          </a:prstGeom>
+          <a:solidFill>
+            <a:srgbClr val="2A2455"/>
+          </a:solidFill>
+          <a:ln w="12700">
+            <a:solidFill>
+              <a:srgbClr val="7C5CFC"/>
+            </a:solidFill>
+          </a:ln>
+          <a:effectLst/>
+        </p:spPr>
+        <p:style>
+          <a:lnRef idx="1">
+            <a:schemeClr val="accent1"/>
+          </a:lnRef>
+          <a:fillRef idx="3">
+            <a:schemeClr val="accent1"/>
+          </a:fillRef>
+          <a:effectRef idx="2">
+            <a:schemeClr val="accent1"/>
+          </a:effectRef>
+          <a:fontRef idx="minor">
+            <a:schemeClr val="lt1"/>
+          </a:fontRef>
+        </p:style>
+        <p:txBody>
+          <a:bodyPr rtlCol="0" anchor="ctr" wrap="none" lIns="0" rIns="0" tIns="0" bIns="0"/>
+          <a:lstStyle/>
+          <a:p>
+            <a:pPr algn="ctr"/>
+            <a:r>
+              <a:rPr sz="2000" b="1">
+                <a:solidFill>
+                  <a:srgbClr val="7C5CFC"/>
+                </a:solidFill>
+              </a:rPr>
+              <a:t>🔒</a:t>
+            </a:r>
+          </a:p>
+        </p:txBody>
+      </p:sp>
+      <p:sp>
+        <p:nvSpPr>
+          <p:cNvPr id="11" name="TextBox 10"/>
+          <p:cNvSpPr txBox="1"/>
+          <p:nvPr/>
+        </p:nvSpPr>
+        <p:spPr>
+          <a:xfrm>
+            <a:off x="8101584" y="2130552"/>
+            <a:ext cx="3520440" cy="457200"/>
+          </a:xfrm>
+          <a:prstGeom prst="rect">
+            <a:avLst/>
+          </a:prstGeom>
+          <a:noFill/>
+        </p:spPr>
+        <p:txBody>
+          <a:bodyPr wrap="square" lIns="0" rIns="0" tIns="0" bIns="0">
+            <a:spAutoFit/>
+          </a:bodyPr>
+          <a:lstStyle/>
+          <a:p>
+            <a:pPr algn="l"/>
+            <a:r>
+              <a:rPr sz="1700" b="1">
+                <a:solidFill>
+                  <a:srgbClr val="FFFFFF"/>
+                </a:solidFill>
+                <a:latin typeface="Calibri"/>
+              </a:rPr>
+              <a:t>Conformité sans effort</a:t>
+            </a:r>
+          </a:p>
+        </p:txBody>
+      </p:sp>
+      <p:sp>
+        <p:nvSpPr>
+          <p:cNvPr id="12" name="TextBox 11"/>
+          <p:cNvSpPr txBox="1"/>
+          <p:nvPr/>
+        </p:nvSpPr>
+        <p:spPr>
+          <a:xfrm>
+            <a:off x="8101584" y="2587752"/>
+            <a:ext cx="3520440" cy="1097280"/>
+          </a:xfrm>
+          <a:prstGeom prst="rect">
+            <a:avLst/>
+          </a:prstGeom>
+          <a:noFill/>
+        </p:spPr>
+        <p:txBody>
+          <a:bodyPr wrap="square" lIns="0" rIns="0" tIns="0" bIns="0">
+            <a:spAutoFit/>
+          </a:bodyPr>
+          <a:lstStyle/>
+          <a:p>
+            <a:pPr algn="l"/>
+            <a:r>
+              <a:rPr sz="1250" b="0">
+                <a:solidFill>
+                  <a:srgbClr val="B7C0D8"/>
+                </a:solidFill>
+                <a:latin typeface="Calibri"/>
+              </a:rPr>
+              <a:t>Aucune donnée réelle transmise à l'IA générative externe, et traçabilité complète : qui a validé, qui a envoyé, quand.</a:t>
+            </a:r>
+          </a:p>
+        </p:txBody>
+      </p:sp>
+      <p:sp>
+        <p:nvSpPr>
+          <p:cNvPr id="13" name="Rounded Rectangle 12"/>
+          <p:cNvSpPr/>
+          <p:nvPr/>
+        </p:nvSpPr>
+        <p:spPr>
+          <a:xfrm>
+            <a:off x="548640" y="3977640"/>
+            <a:ext cx="11109960" cy="1691640"/>
+          </a:xfrm>
+          <a:prstGeom prst="roundRect">
+            <a:avLst>
+              <a:gd name="adj" fmla="val 6000"/>
+            </a:avLst>
+          </a:prstGeom>
+          <a:solidFill>
+            <a:srgbClr val="16304F"/>
+          </a:solidFill>
+          <a:ln>
+            <a:noFill/>
+          </a:ln>
+          <a:effectLst/>
+        </p:spPr>
+        <p:style>
+          <a:lnRef idx="1">
+            <a:schemeClr val="accent1"/>
+          </a:lnRef>
+          <a:fillRef idx="3">
+            <a:schemeClr val="accent1"/>
+          </a:fillRef>
+          <a:effectRef idx="2">
+            <a:schemeClr val="accent1"/>
+          </a:effectRef>
+          <a:fontRef idx="minor">
+            <a:schemeClr val="lt1"/>
+          </a:fontRef>
+        </p:style>
+        <p:txBody>
+          <a:bodyPr rtlCol="0" anchor="ctr"/>
+          <a:lstStyle/>
+          <a:p>
+            <a:pPr algn="ctr"/>
+          </a:p>
+        </p:txBody>
+      </p:sp>
+      <p:sp>
+        <p:nvSpPr>
+          <p:cNvPr id="14" name="TextBox 13"/>
+          <p:cNvSpPr txBox="1"/>
+          <p:nvPr/>
+        </p:nvSpPr>
+        <p:spPr>
+          <a:xfrm>
+            <a:off x="914400" y="4206240"/>
+            <a:ext cx="10378440" cy="914400"/>
+          </a:xfrm>
+          <a:prstGeom prst="rect">
+            <a:avLst/>
+          </a:prstGeom>
+          <a:noFill/>
+        </p:spPr>
+        <p:txBody>
+          <a:bodyPr wrap="square" lIns="0" rIns="0">
+            <a:spAutoFit/>
+          </a:bodyPr>
+          <a:lstStyle/>
+          <a:p>
+            <a:r>
+              <a:rPr sz="1500" b="1">
+                <a:solidFill>
+                  <a:srgbClr val="7C5CFC"/>
+                </a:solidFill>
+                <a:latin typeface="Calibri"/>
+              </a:rPr>
+              <a:t>Retour sur investissement estimé : </a:t>
+            </a:r>
+            <a:r>
+              <a:rPr sz="1500">
+                <a:solidFill>
+                  <a:srgbClr val="FFFFFF"/>
+                </a:solidFill>
+                <a:latin typeface="Calibri"/>
+              </a:rPr>
+              <a:t>moins de temps passé à rédiger et corriger un courrier sensible à la main, et un seul point de validation humaine au lieu d'un aller-retour email répété entre secrétaire et manager.</a:t>
+            </a:r>
+          </a:p>
+        </p:txBody>
+      </p:sp>
+      <p:sp>
+        <p:nvSpPr>
+          <p:cNvPr id="15" name="TextBox 14"/>
+          <p:cNvSpPr txBox="1"/>
+          <p:nvPr/>
+        </p:nvSpPr>
+        <p:spPr>
+          <a:xfrm>
+            <a:off x="914400" y="5166360"/>
+            <a:ext cx="10378440" cy="411480"/>
+          </a:xfrm>
+          <a:prstGeom prst="rect">
+            <a:avLst/>
+          </a:prstGeom>
+          <a:noFill/>
+        </p:spPr>
+        <p:txBody>
+          <a:bodyPr wrap="square" lIns="0" rIns="0" tIns="0" bIns="0">
+            <a:spAutoFit/>
+          </a:bodyPr>
+          <a:lstStyle/>
+          <a:p>
+            <a:pPr algn="l"/>
+            <a:r>
+              <a:rPr sz="1150" b="0">
+                <a:solidFill>
+                  <a:srgbClr val="8A93AC"/>
+                </a:solidFill>
+                <a:latin typeface="Calibri"/>
+              </a:rPr>
+              <a:t>Ordre de grandeur indicatif, à valider selon le volume réel de courriers sensibles traités par l'organisation.</a:t>
+            </a:r>
+          </a:p>
+        </p:txBody>
+      </p:sp>
+      <p:sp>
+        <p:nvSpPr>
+          <p:cNvPr id="16" name="TextBox 15"/>
+          <p:cNvSpPr txBox="1"/>
           <p:nvPr/>
         </p:nvSpPr>
         <p:spPr>
@@ -2712,34 +3552,30 @@
             <a:avLst/>
           </a:prstGeom>
           <a:noFill/>
-          <a:ln/>
-        </p:spPr>
-        <p:txBody>
-          <a:bodyPr wrap="square" rtlCol="0" anchor="ctr"/>
-          <a:lstStyle/>
-          <a:p>
-            <a:pPr marL="0" indent="0">
-              <a:buNone/>
-            </a:pPr>
-            <a:r>
-              <a:rPr lang="en-US" sz="900" dirty="0">
+        </p:spPr>
+        <p:txBody>
+          <a:bodyPr wrap="square" lIns="0" rIns="0" tIns="0" bIns="0">
+            <a:spAutoFit/>
+          </a:bodyPr>
+          <a:lstStyle/>
+          <a:p>
+            <a:pPr algn="l"/>
+            <a:r>
+              <a:rPr sz="900" b="0">
                 <a:solidFill>
                   <a:srgbClr val="8A93AC"/>
                 </a:solidFill>
-                <a:latin typeface="Calibri" pitchFamily="34" charset="0"/>
-                <a:ea typeface="Calibri" pitchFamily="34" charset="-122"/>
-                <a:cs typeface="Calibri" pitchFamily="34" charset="-120"/>
-              </a:rPr>
-              <a:t>contact@transferai.ci  •  www.transferai.ci</a:t>
-            </a:r>
-            <a:endParaRPr lang="en-US" sz="900" dirty="0"/>
-          </a:p>
-        </p:txBody>
-      </p:sp>
-      <p:sp>
-        <p:nvSpPr>
-          <p:cNvPr id="29" name="Text 27"/>
-          <p:cNvSpPr/>
+                <a:latin typeface="Calibri"/>
+              </a:rPr>
+              <a:t>TransferAI Africa  •  Le Courrier Confidentiel Généré par IA</a:t>
+            </a:r>
+          </a:p>
+        </p:txBody>
+      </p:sp>
+      <p:sp>
+        <p:nvSpPr>
+          <p:cNvPr id="17" name="TextBox 16"/>
+          <p:cNvSpPr txBox="1"/>
           <p:nvPr/>
         </p:nvSpPr>
         <p:spPr>
@@ -2751,27 +3587,1475 @@
             <a:avLst/>
           </a:prstGeom>
           <a:noFill/>
-          <a:ln/>
-        </p:spPr>
-        <p:txBody>
-          <a:bodyPr wrap="square" rtlCol="0" anchor="ctr"/>
-          <a:lstStyle/>
-          <a:p>
-            <a:pPr marL="0" indent="0" algn="r">
-              <a:buNone/>
-            </a:pPr>
-            <a:r>
-              <a:rPr lang="en-US" sz="900" dirty="0">
+        </p:spPr>
+        <p:txBody>
+          <a:bodyPr wrap="square" lIns="0" rIns="0" tIns="0" bIns="0">
+            <a:spAutoFit/>
+          </a:bodyPr>
+          <a:lstStyle/>
+          <a:p>
+            <a:pPr algn="l"/>
+            <a:r>
+              <a:rPr sz="900" b="0">
                 <a:solidFill>
                   <a:srgbClr val="8A93AC"/>
                 </a:solidFill>
-                <a:latin typeface="Calibri" pitchFamily="34" charset="0"/>
-                <a:ea typeface="Calibri" pitchFamily="34" charset="-122"/>
-                <a:cs typeface="Calibri" pitchFamily="34" charset="-120"/>
+                <a:latin typeface="Calibri"/>
               </a:rPr>
               <a:t>18 juillet 2026</a:t>
             </a:r>
-            <a:endParaRPr lang="en-US" sz="900" dirty="0"/>
+          </a:p>
+        </p:txBody>
+      </p:sp>
+    </p:spTree>
+  </p:cSld>
+  <p:clrMapOvr>
+    <a:masterClrMapping/>
+  </p:clrMapOvr>
+</p:sld>
+</file>
+
+<file path=ppt/slides/slide5.xml><?xml version="1.0" encoding="utf-8"?>
+<p:sld xmlns:a="http://schemas.openxmlformats.org/drawingml/2006/main" xmlns:p="http://schemas.openxmlformats.org/presentationml/2006/main" xmlns:r="http://schemas.openxmlformats.org/officeDocument/2006/relationships">
+  <p:cSld>
+    <p:bg>
+      <p:bgPr>
+        <a:solidFill>
+          <a:srgbClr val="10263F"/>
+        </a:solidFill>
+        <a:effectLst/>
+      </p:bgPr>
+    </p:bg>
+    <p:spTree>
+      <p:nvGrpSpPr>
+        <p:cNvPr id="1" name=""/>
+        <p:cNvGrpSpPr/>
+        <p:nvPr/>
+      </p:nvGrpSpPr>
+      <p:grpSpPr/>
+      <p:sp>
+        <p:nvSpPr>
+          <p:cNvPr id="2" name="TextBox 1"/>
+          <p:cNvSpPr txBox="1"/>
+          <p:nvPr/>
+        </p:nvSpPr>
+        <p:spPr>
+          <a:xfrm>
+            <a:off x="548640" y="457200"/>
+            <a:ext cx="10515600" cy="502920"/>
+          </a:xfrm>
+          <a:prstGeom prst="rect">
+            <a:avLst/>
+          </a:prstGeom>
+          <a:noFill/>
+        </p:spPr>
+        <p:txBody>
+          <a:bodyPr wrap="square" lIns="0" rIns="0" tIns="0" bIns="0">
+            <a:spAutoFit/>
+          </a:bodyPr>
+          <a:lstStyle/>
+          <a:p>
+            <a:pPr algn="l"/>
+            <a:r>
+              <a:rPr sz="2600" b="1">
+                <a:solidFill>
+                  <a:srgbClr val="FFFFFF"/>
+                </a:solidFill>
+                <a:latin typeface="Calibri"/>
+              </a:rPr>
+              <a:t>Le même principe, pour vos réunions les plus sensibles</a:t>
+            </a:r>
+          </a:p>
+        </p:txBody>
+      </p:sp>
+      <p:sp>
+        <p:nvSpPr>
+          <p:cNvPr id="3" name="TextBox 2"/>
+          <p:cNvSpPr txBox="1"/>
+          <p:nvPr/>
+        </p:nvSpPr>
+        <p:spPr>
+          <a:xfrm>
+            <a:off x="548640" y="960120"/>
+            <a:ext cx="10058400" cy="365760"/>
+          </a:xfrm>
+          <a:prstGeom prst="rect">
+            <a:avLst/>
+          </a:prstGeom>
+          <a:noFill/>
+        </p:spPr>
+        <p:txBody>
+          <a:bodyPr wrap="square" lIns="0" rIns="0" tIns="0" bIns="0">
+            <a:spAutoFit/>
+          </a:bodyPr>
+          <a:lstStyle/>
+          <a:p>
+            <a:pPr algn="l"/>
+            <a:r>
+              <a:rPr sz="1300" b="0">
+                <a:solidFill>
+                  <a:srgbClr val="B7C0D8"/>
+                </a:solidFill>
+                <a:latin typeface="Calibri"/>
+              </a:rPr>
+              <a:t>Compte rendu confidentiel multi-plateformes (Zoom, Webex, Teams, Drive, dictaphone) — pseudonymisé avant tout appel à l'IA.</a:t>
+            </a:r>
+          </a:p>
+        </p:txBody>
+      </p:sp>
+      <p:sp>
+        <p:nvSpPr>
+          <p:cNvPr id="4" name="Rounded Rectangle 3"/>
+          <p:cNvSpPr/>
+          <p:nvPr/>
+        </p:nvSpPr>
+        <p:spPr>
+          <a:xfrm>
+            <a:off x="548640" y="1500000"/>
+            <a:ext cx="2066544" cy="1250000"/>
+          </a:xfrm>
+          <a:prstGeom prst="roundRect">
+            <a:avLst>
+              <a:gd name="adj" fmla="val 6000"/>
+            </a:avLst>
+          </a:prstGeom>
+          <a:solidFill>
+            <a:srgbClr val="16304F"/>
+          </a:solidFill>
+          <a:ln>
+            <a:noFill/>
+          </a:ln>
+          <a:effectLst/>
+        </p:spPr>
+        <p:style>
+          <a:lnRef idx="1">
+            <a:schemeClr val="accent1"/>
+          </a:lnRef>
+          <a:fillRef idx="3">
+            <a:schemeClr val="accent1"/>
+          </a:fillRef>
+          <a:effectRef idx="2">
+            <a:schemeClr val="accent1"/>
+          </a:effectRef>
+          <a:fontRef idx="minor">
+            <a:schemeClr val="lt1"/>
+          </a:fontRef>
+        </p:style>
+        <p:txBody>
+          <a:bodyPr rtlCol="0" anchor="ctr"/>
+          <a:lstStyle/>
+          <a:p>
+            <a:pPr algn="ctr"/>
+          </a:p>
+        </p:txBody>
+      </p:sp>
+      <p:sp>
+        <p:nvSpPr>
+          <p:cNvPr id="5" name="TextBox 4"/>
+          <p:cNvSpPr txBox="1"/>
+          <p:nvPr/>
+        </p:nvSpPr>
+        <p:spPr>
+          <a:xfrm>
+            <a:off x="685800" y="1637160"/>
+            <a:ext cx="1792224" cy="274320"/>
+          </a:xfrm>
+          <a:prstGeom prst="rect">
+            <a:avLst/>
+          </a:prstGeom>
+          <a:noFill/>
+        </p:spPr>
+        <p:txBody>
+          <a:bodyPr wrap="square" lIns="0" rIns="0" tIns="0" bIns="0">
+            <a:spAutoFit/>
+          </a:bodyPr>
+          <a:lstStyle/>
+          <a:p>
+            <a:pPr algn="l"/>
+            <a:r>
+              <a:rPr sz="1600" b="1">
+                <a:solidFill>
+                  <a:srgbClr val="7C5CFC"/>
+                </a:solidFill>
+                <a:latin typeface="Calibri"/>
+              </a:rPr>
+              <a:t>1</a:t>
+            </a:r>
+          </a:p>
+        </p:txBody>
+      </p:sp>
+      <p:sp>
+        <p:nvSpPr>
+          <p:cNvPr id="6" name="TextBox 5"/>
+          <p:cNvSpPr txBox="1"/>
+          <p:nvPr/>
+        </p:nvSpPr>
+        <p:spPr>
+          <a:xfrm>
+            <a:off x="685800" y="1911480"/>
+            <a:ext cx="1792224" cy="411480"/>
+          </a:xfrm>
+          <a:prstGeom prst="rect">
+            <a:avLst/>
+          </a:prstGeom>
+          <a:noFill/>
+        </p:spPr>
+        <p:txBody>
+          <a:bodyPr wrap="square" lIns="0" rIns="0" tIns="0" bIns="0">
+            <a:spAutoFit/>
+          </a:bodyPr>
+          <a:lstStyle/>
+          <a:p>
+            <a:pPr algn="l"/>
+            <a:r>
+              <a:rPr sz="1150" b="1">
+                <a:solidFill>
+                  <a:srgbClr val="FFFFFF"/>
+                </a:solidFill>
+                <a:latin typeface="Calibri"/>
+              </a:rPr>
+              <a:t>Ingestion audio</a:t>
+            </a:r>
+          </a:p>
+        </p:txBody>
+      </p:sp>
+      <p:sp>
+        <p:nvSpPr>
+          <p:cNvPr id="7" name="TextBox 6"/>
+          <p:cNvSpPr txBox="1"/>
+          <p:nvPr/>
+        </p:nvSpPr>
+        <p:spPr>
+          <a:xfrm>
+            <a:off x="685800" y="2300100"/>
+            <a:ext cx="1792224" cy="411480"/>
+          </a:xfrm>
+          <a:prstGeom prst="rect">
+            <a:avLst/>
+          </a:prstGeom>
+          <a:noFill/>
+        </p:spPr>
+        <p:txBody>
+          <a:bodyPr wrap="square" lIns="0" rIns="0" tIns="0" bIns="0">
+            <a:spAutoFit/>
+          </a:bodyPr>
+          <a:lstStyle/>
+          <a:p>
+            <a:pPr algn="l"/>
+            <a:r>
+              <a:rPr sz="950" b="0">
+                <a:solidFill>
+                  <a:srgbClr val="B7C0D8"/>
+                </a:solidFill>
+                <a:latin typeface="Calibri"/>
+              </a:rPr>
+              <a:t>Zoom, Webex, Teams, Drive, dictaphone</a:t>
+            </a:r>
+          </a:p>
+        </p:txBody>
+      </p:sp>
+      <p:sp>
+        <p:nvSpPr>
+          <p:cNvPr id="8" name="TextBox 7"/>
+          <p:cNvSpPr txBox="1"/>
+          <p:nvPr/>
+        </p:nvSpPr>
+        <p:spPr>
+          <a:xfrm>
+            <a:off x="2615184" y="1987840"/>
+            <a:ext cx="137160" cy="274320"/>
+          </a:xfrm>
+          <a:prstGeom prst="rect">
+            <a:avLst/>
+          </a:prstGeom>
+          <a:noFill/>
+        </p:spPr>
+        <p:txBody>
+          <a:bodyPr wrap="square" lIns="0" rIns="0" tIns="0" bIns="0">
+            <a:spAutoFit/>
+          </a:bodyPr>
+          <a:lstStyle/>
+          <a:p>
+            <a:pPr algn="ctr"/>
+            <a:r>
+              <a:rPr sz="1600" b="1">
+                <a:solidFill>
+                  <a:srgbClr val="7C5CFC"/>
+                </a:solidFill>
+                <a:latin typeface="Calibri"/>
+              </a:rPr>
+              <a:t>›</a:t>
+            </a:r>
+          </a:p>
+        </p:txBody>
+      </p:sp>
+      <p:sp>
+        <p:nvSpPr>
+          <p:cNvPr id="9" name="Rounded Rectangle 8"/>
+          <p:cNvSpPr/>
+          <p:nvPr/>
+        </p:nvSpPr>
+        <p:spPr>
+          <a:xfrm>
+            <a:off x="2752344" y="1500000"/>
+            <a:ext cx="2066544" cy="1250000"/>
+          </a:xfrm>
+          <a:prstGeom prst="roundRect">
+            <a:avLst>
+              <a:gd name="adj" fmla="val 6000"/>
+            </a:avLst>
+          </a:prstGeom>
+          <a:solidFill>
+            <a:srgbClr val="16304F"/>
+          </a:solidFill>
+          <a:ln>
+            <a:noFill/>
+          </a:ln>
+          <a:effectLst/>
+        </p:spPr>
+        <p:style>
+          <a:lnRef idx="1">
+            <a:schemeClr val="accent1"/>
+          </a:lnRef>
+          <a:fillRef idx="3">
+            <a:schemeClr val="accent1"/>
+          </a:fillRef>
+          <a:effectRef idx="2">
+            <a:schemeClr val="accent1"/>
+          </a:effectRef>
+          <a:fontRef idx="minor">
+            <a:schemeClr val="lt1"/>
+          </a:fontRef>
+        </p:style>
+        <p:txBody>
+          <a:bodyPr rtlCol="0" anchor="ctr"/>
+          <a:lstStyle/>
+          <a:p>
+            <a:pPr algn="ctr"/>
+          </a:p>
+        </p:txBody>
+      </p:sp>
+      <p:sp>
+        <p:nvSpPr>
+          <p:cNvPr id="10" name="TextBox 9"/>
+          <p:cNvSpPr txBox="1"/>
+          <p:nvPr/>
+        </p:nvSpPr>
+        <p:spPr>
+          <a:xfrm>
+            <a:off x="2889504" y="1637160"/>
+            <a:ext cx="1792224" cy="274320"/>
+          </a:xfrm>
+          <a:prstGeom prst="rect">
+            <a:avLst/>
+          </a:prstGeom>
+          <a:noFill/>
+        </p:spPr>
+        <p:txBody>
+          <a:bodyPr wrap="square" lIns="0" rIns="0" tIns="0" bIns="0">
+            <a:spAutoFit/>
+          </a:bodyPr>
+          <a:lstStyle/>
+          <a:p>
+            <a:pPr algn="l"/>
+            <a:r>
+              <a:rPr sz="1600" b="1">
+                <a:solidFill>
+                  <a:srgbClr val="7C5CFC"/>
+                </a:solidFill>
+                <a:latin typeface="Calibri"/>
+              </a:rPr>
+              <a:t>2</a:t>
+            </a:r>
+          </a:p>
+        </p:txBody>
+      </p:sp>
+      <p:sp>
+        <p:nvSpPr>
+          <p:cNvPr id="11" name="TextBox 10"/>
+          <p:cNvSpPr txBox="1"/>
+          <p:nvPr/>
+        </p:nvSpPr>
+        <p:spPr>
+          <a:xfrm>
+            <a:off x="2889504" y="1911480"/>
+            <a:ext cx="1792224" cy="411480"/>
+          </a:xfrm>
+          <a:prstGeom prst="rect">
+            <a:avLst/>
+          </a:prstGeom>
+          <a:noFill/>
+        </p:spPr>
+        <p:txBody>
+          <a:bodyPr wrap="square" lIns="0" rIns="0" tIns="0" bIns="0">
+            <a:spAutoFit/>
+          </a:bodyPr>
+          <a:lstStyle/>
+          <a:p>
+            <a:pPr algn="l"/>
+            <a:r>
+              <a:rPr sz="1150" b="1">
+                <a:solidFill>
+                  <a:srgbClr val="FFFFFF"/>
+                </a:solidFill>
+                <a:latin typeface="Calibri"/>
+              </a:rPr>
+              <a:t>Pseudonymisation locale</a:t>
+            </a:r>
+          </a:p>
+        </p:txBody>
+      </p:sp>
+      <p:sp>
+        <p:nvSpPr>
+          <p:cNvPr id="12" name="TextBox 11"/>
+          <p:cNvSpPr txBox="1"/>
+          <p:nvPr/>
+        </p:nvSpPr>
+        <p:spPr>
+          <a:xfrm>
+            <a:off x="2889504" y="2300100"/>
+            <a:ext cx="1792224" cy="411480"/>
+          </a:xfrm>
+          <a:prstGeom prst="rect">
+            <a:avLst/>
+          </a:prstGeom>
+          <a:noFill/>
+        </p:spPr>
+        <p:txBody>
+          <a:bodyPr wrap="square" lIns="0" rIns="0" tIns="0" bIns="0">
+            <a:spAutoFit/>
+          </a:bodyPr>
+          <a:lstStyle/>
+          <a:p>
+            <a:pPr algn="l"/>
+            <a:r>
+              <a:rPr sz="950" b="0">
+                <a:solidFill>
+                  <a:srgbClr val="B7C0D8"/>
+                </a:solidFill>
+                <a:latin typeface="Calibri"/>
+              </a:rPr>
+              <a:t>Détection élargie + regex compatible accents</a:t>
+            </a:r>
+          </a:p>
+        </p:txBody>
+      </p:sp>
+      <p:sp>
+        <p:nvSpPr>
+          <p:cNvPr id="13" name="TextBox 12"/>
+          <p:cNvSpPr txBox="1"/>
+          <p:nvPr/>
+        </p:nvSpPr>
+        <p:spPr>
+          <a:xfrm>
+            <a:off x="4818888" y="1987840"/>
+            <a:ext cx="137160" cy="274320"/>
+          </a:xfrm>
+          <a:prstGeom prst="rect">
+            <a:avLst/>
+          </a:prstGeom>
+          <a:noFill/>
+        </p:spPr>
+        <p:txBody>
+          <a:bodyPr wrap="square" lIns="0" rIns="0" tIns="0" bIns="0">
+            <a:spAutoFit/>
+          </a:bodyPr>
+          <a:lstStyle/>
+          <a:p>
+            <a:pPr algn="ctr"/>
+            <a:r>
+              <a:rPr sz="1600" b="1">
+                <a:solidFill>
+                  <a:srgbClr val="7C5CFC"/>
+                </a:solidFill>
+                <a:latin typeface="Calibri"/>
+              </a:rPr>
+              <a:t>›</a:t>
+            </a:r>
+          </a:p>
+        </p:txBody>
+      </p:sp>
+      <p:sp>
+        <p:nvSpPr>
+          <p:cNvPr id="14" name="Rounded Rectangle 13"/>
+          <p:cNvSpPr/>
+          <p:nvPr/>
+        </p:nvSpPr>
+        <p:spPr>
+          <a:xfrm>
+            <a:off x="4956048" y="1500000"/>
+            <a:ext cx="2066544" cy="1250000"/>
+          </a:xfrm>
+          <a:prstGeom prst="roundRect">
+            <a:avLst>
+              <a:gd name="adj" fmla="val 6000"/>
+            </a:avLst>
+          </a:prstGeom>
+          <a:solidFill>
+            <a:srgbClr val="16304F"/>
+          </a:solidFill>
+          <a:ln>
+            <a:noFill/>
+          </a:ln>
+          <a:effectLst/>
+        </p:spPr>
+        <p:style>
+          <a:lnRef idx="1">
+            <a:schemeClr val="accent1"/>
+          </a:lnRef>
+          <a:fillRef idx="3">
+            <a:schemeClr val="accent1"/>
+          </a:fillRef>
+          <a:effectRef idx="2">
+            <a:schemeClr val="accent1"/>
+          </a:effectRef>
+          <a:fontRef idx="minor">
+            <a:schemeClr val="lt1"/>
+          </a:fontRef>
+        </p:style>
+        <p:txBody>
+          <a:bodyPr rtlCol="0" anchor="ctr"/>
+          <a:lstStyle/>
+          <a:p>
+            <a:pPr algn="ctr"/>
+          </a:p>
+        </p:txBody>
+      </p:sp>
+      <p:sp>
+        <p:nvSpPr>
+          <p:cNvPr id="15" name="TextBox 14"/>
+          <p:cNvSpPr txBox="1"/>
+          <p:nvPr/>
+        </p:nvSpPr>
+        <p:spPr>
+          <a:xfrm>
+            <a:off x="5093208" y="1637160"/>
+            <a:ext cx="1792224" cy="274320"/>
+          </a:xfrm>
+          <a:prstGeom prst="rect">
+            <a:avLst/>
+          </a:prstGeom>
+          <a:noFill/>
+        </p:spPr>
+        <p:txBody>
+          <a:bodyPr wrap="square" lIns="0" rIns="0" tIns="0" bIns="0">
+            <a:spAutoFit/>
+          </a:bodyPr>
+          <a:lstStyle/>
+          <a:p>
+            <a:pPr algn="l"/>
+            <a:r>
+              <a:rPr sz="1600" b="1">
+                <a:solidFill>
+                  <a:srgbClr val="7C5CFC"/>
+                </a:solidFill>
+                <a:latin typeface="Calibri"/>
+              </a:rPr>
+              <a:t>3</a:t>
+            </a:r>
+          </a:p>
+        </p:txBody>
+      </p:sp>
+      <p:sp>
+        <p:nvSpPr>
+          <p:cNvPr id="16" name="TextBox 15"/>
+          <p:cNvSpPr txBox="1"/>
+          <p:nvPr/>
+        </p:nvSpPr>
+        <p:spPr>
+          <a:xfrm>
+            <a:off x="5093208" y="1911480"/>
+            <a:ext cx="1792224" cy="411480"/>
+          </a:xfrm>
+          <a:prstGeom prst="rect">
+            <a:avLst/>
+          </a:prstGeom>
+          <a:noFill/>
+        </p:spPr>
+        <p:txBody>
+          <a:bodyPr wrap="square" lIns="0" rIns="0" tIns="0" bIns="0">
+            <a:spAutoFit/>
+          </a:bodyPr>
+          <a:lstStyle/>
+          <a:p>
+            <a:pPr algn="l"/>
+            <a:r>
+              <a:rPr sz="1150" b="1">
+                <a:solidFill>
+                  <a:srgbClr val="FFFFFF"/>
+                </a:solidFill>
+                <a:latin typeface="Calibri"/>
+              </a:rPr>
+              <a:t>OpenAI</a:t>
+            </a:r>
+          </a:p>
+        </p:txBody>
+      </p:sp>
+      <p:sp>
+        <p:nvSpPr>
+          <p:cNvPr id="17" name="TextBox 16"/>
+          <p:cNvSpPr txBox="1"/>
+          <p:nvPr/>
+        </p:nvSpPr>
+        <p:spPr>
+          <a:xfrm>
+            <a:off x="5093208" y="2300100"/>
+            <a:ext cx="1792224" cy="411480"/>
+          </a:xfrm>
+          <a:prstGeom prst="rect">
+            <a:avLst/>
+          </a:prstGeom>
+          <a:noFill/>
+        </p:spPr>
+        <p:txBody>
+          <a:bodyPr wrap="square" lIns="0" rIns="0" tIns="0" bIns="0">
+            <a:spAutoFit/>
+          </a:bodyPr>
+          <a:lstStyle/>
+          <a:p>
+            <a:pPr algn="l"/>
+            <a:r>
+              <a:rPr sz="950" b="0">
+                <a:solidFill>
+                  <a:srgbClr val="B7C0D8"/>
+                </a:solidFill>
+                <a:latin typeface="Calibri"/>
+              </a:rPr>
+              <a:t>Rapport structuré, sanitisé</a:t>
+            </a:r>
+          </a:p>
+        </p:txBody>
+      </p:sp>
+      <p:sp>
+        <p:nvSpPr>
+          <p:cNvPr id="18" name="TextBox 17"/>
+          <p:cNvSpPr txBox="1"/>
+          <p:nvPr/>
+        </p:nvSpPr>
+        <p:spPr>
+          <a:xfrm>
+            <a:off x="7022592" y="1987840"/>
+            <a:ext cx="137160" cy="274320"/>
+          </a:xfrm>
+          <a:prstGeom prst="rect">
+            <a:avLst/>
+          </a:prstGeom>
+          <a:noFill/>
+        </p:spPr>
+        <p:txBody>
+          <a:bodyPr wrap="square" lIns="0" rIns="0" tIns="0" bIns="0">
+            <a:spAutoFit/>
+          </a:bodyPr>
+          <a:lstStyle/>
+          <a:p>
+            <a:pPr algn="ctr"/>
+            <a:r>
+              <a:rPr sz="1600" b="1">
+                <a:solidFill>
+                  <a:srgbClr val="7C5CFC"/>
+                </a:solidFill>
+                <a:latin typeface="Calibri"/>
+              </a:rPr>
+              <a:t>›</a:t>
+            </a:r>
+          </a:p>
+        </p:txBody>
+      </p:sp>
+      <p:sp>
+        <p:nvSpPr>
+          <p:cNvPr id="19" name="Rounded Rectangle 18"/>
+          <p:cNvSpPr/>
+          <p:nvPr/>
+        </p:nvSpPr>
+        <p:spPr>
+          <a:xfrm>
+            <a:off x="7159752" y="1500000"/>
+            <a:ext cx="2066544" cy="1250000"/>
+          </a:xfrm>
+          <a:prstGeom prst="roundRect">
+            <a:avLst>
+              <a:gd name="adj" fmla="val 6000"/>
+            </a:avLst>
+          </a:prstGeom>
+          <a:solidFill>
+            <a:srgbClr val="16304F"/>
+          </a:solidFill>
+          <a:ln>
+            <a:noFill/>
+          </a:ln>
+          <a:effectLst/>
+        </p:spPr>
+        <p:style>
+          <a:lnRef idx="1">
+            <a:schemeClr val="accent1"/>
+          </a:lnRef>
+          <a:fillRef idx="3">
+            <a:schemeClr val="accent1"/>
+          </a:fillRef>
+          <a:effectRef idx="2">
+            <a:schemeClr val="accent1"/>
+          </a:effectRef>
+          <a:fontRef idx="minor">
+            <a:schemeClr val="lt1"/>
+          </a:fontRef>
+        </p:style>
+        <p:txBody>
+          <a:bodyPr rtlCol="0" anchor="ctr"/>
+          <a:lstStyle/>
+          <a:p>
+            <a:pPr algn="ctr"/>
+          </a:p>
+        </p:txBody>
+      </p:sp>
+      <p:sp>
+        <p:nvSpPr>
+          <p:cNvPr id="20" name="TextBox 19"/>
+          <p:cNvSpPr txBox="1"/>
+          <p:nvPr/>
+        </p:nvSpPr>
+        <p:spPr>
+          <a:xfrm>
+            <a:off x="7296912" y="1637160"/>
+            <a:ext cx="1792224" cy="274320"/>
+          </a:xfrm>
+          <a:prstGeom prst="rect">
+            <a:avLst/>
+          </a:prstGeom>
+          <a:noFill/>
+        </p:spPr>
+        <p:txBody>
+          <a:bodyPr wrap="square" lIns="0" rIns="0" tIns="0" bIns="0">
+            <a:spAutoFit/>
+          </a:bodyPr>
+          <a:lstStyle/>
+          <a:p>
+            <a:pPr algn="l"/>
+            <a:r>
+              <a:rPr sz="1600" b="1">
+                <a:solidFill>
+                  <a:srgbClr val="7C5CFC"/>
+                </a:solidFill>
+                <a:latin typeface="Calibri"/>
+              </a:rPr>
+              <a:t>4</a:t>
+            </a:r>
+          </a:p>
+        </p:txBody>
+      </p:sp>
+      <p:sp>
+        <p:nvSpPr>
+          <p:cNvPr id="21" name="TextBox 20"/>
+          <p:cNvSpPr txBox="1"/>
+          <p:nvPr/>
+        </p:nvSpPr>
+        <p:spPr>
+          <a:xfrm>
+            <a:off x="7296912" y="1911480"/>
+            <a:ext cx="1792224" cy="411480"/>
+          </a:xfrm>
+          <a:prstGeom prst="rect">
+            <a:avLst/>
+          </a:prstGeom>
+          <a:noFill/>
+        </p:spPr>
+        <p:txBody>
+          <a:bodyPr wrap="square" lIns="0" rIns="0" tIns="0" bIns="0">
+            <a:spAutoFit/>
+          </a:bodyPr>
+          <a:lstStyle/>
+          <a:p>
+            <a:pPr algn="l"/>
+            <a:r>
+              <a:rPr sz="1150" b="1">
+                <a:solidFill>
+                  <a:srgbClr val="FFFFFF"/>
+                </a:solidFill>
+                <a:latin typeface="Calibri"/>
+              </a:rPr>
+              <a:t>Validation sécurisée</a:t>
+            </a:r>
+          </a:p>
+        </p:txBody>
+      </p:sp>
+      <p:sp>
+        <p:nvSpPr>
+          <p:cNvPr id="22" name="TextBox 21"/>
+          <p:cNvSpPr txBox="1"/>
+          <p:nvPr/>
+        </p:nvSpPr>
+        <p:spPr>
+          <a:xfrm>
+            <a:off x="7296912" y="2300100"/>
+            <a:ext cx="1792224" cy="411480"/>
+          </a:xfrm>
+          <a:prstGeom prst="rect">
+            <a:avLst/>
+          </a:prstGeom>
+          <a:noFill/>
+        </p:spPr>
+        <p:txBody>
+          <a:bodyPr wrap="square" lIns="0" rIns="0" tIns="0" bIns="0">
+            <a:spAutoFit/>
+          </a:bodyPr>
+          <a:lstStyle/>
+          <a:p>
+            <a:pPr algn="l"/>
+            <a:r>
+              <a:rPr sz="950" b="0">
+                <a:solidFill>
+                  <a:srgbClr val="B7C0D8"/>
+                </a:solidFill>
+                <a:latin typeface="Calibri"/>
+              </a:rPr>
+              <a:t>Lien à token + page de confirmation</a:t>
+            </a:r>
+          </a:p>
+        </p:txBody>
+      </p:sp>
+      <p:sp>
+        <p:nvSpPr>
+          <p:cNvPr id="23" name="TextBox 22"/>
+          <p:cNvSpPr txBox="1"/>
+          <p:nvPr/>
+        </p:nvSpPr>
+        <p:spPr>
+          <a:xfrm>
+            <a:off x="9226296" y="1987840"/>
+            <a:ext cx="137160" cy="274320"/>
+          </a:xfrm>
+          <a:prstGeom prst="rect">
+            <a:avLst/>
+          </a:prstGeom>
+          <a:noFill/>
+        </p:spPr>
+        <p:txBody>
+          <a:bodyPr wrap="square" lIns="0" rIns="0" tIns="0" bIns="0">
+            <a:spAutoFit/>
+          </a:bodyPr>
+          <a:lstStyle/>
+          <a:p>
+            <a:pPr algn="ctr"/>
+            <a:r>
+              <a:rPr sz="1600" b="1">
+                <a:solidFill>
+                  <a:srgbClr val="7C5CFC"/>
+                </a:solidFill>
+                <a:latin typeface="Calibri"/>
+              </a:rPr>
+              <a:t>›</a:t>
+            </a:r>
+          </a:p>
+        </p:txBody>
+      </p:sp>
+      <p:sp>
+        <p:nvSpPr>
+          <p:cNvPr id="24" name="Rounded Rectangle 23"/>
+          <p:cNvSpPr/>
+          <p:nvPr/>
+        </p:nvSpPr>
+        <p:spPr>
+          <a:xfrm>
+            <a:off x="9363456" y="1500000"/>
+            <a:ext cx="2066544" cy="1250000"/>
+          </a:xfrm>
+          <a:prstGeom prst="roundRect">
+            <a:avLst>
+              <a:gd name="adj" fmla="val 6000"/>
+            </a:avLst>
+          </a:prstGeom>
+          <a:solidFill>
+            <a:srgbClr val="16304F"/>
+          </a:solidFill>
+          <a:ln>
+            <a:noFill/>
+          </a:ln>
+          <a:effectLst/>
+        </p:spPr>
+        <p:style>
+          <a:lnRef idx="1">
+            <a:schemeClr val="accent1"/>
+          </a:lnRef>
+          <a:fillRef idx="3">
+            <a:schemeClr val="accent1"/>
+          </a:fillRef>
+          <a:effectRef idx="2">
+            <a:schemeClr val="accent1"/>
+          </a:effectRef>
+          <a:fontRef idx="minor">
+            <a:schemeClr val="lt1"/>
+          </a:fontRef>
+        </p:style>
+        <p:txBody>
+          <a:bodyPr rtlCol="0" anchor="ctr"/>
+          <a:lstStyle/>
+          <a:p>
+            <a:pPr algn="ctr"/>
+          </a:p>
+        </p:txBody>
+      </p:sp>
+      <p:sp>
+        <p:nvSpPr>
+          <p:cNvPr id="25" name="TextBox 24"/>
+          <p:cNvSpPr txBox="1"/>
+          <p:nvPr/>
+        </p:nvSpPr>
+        <p:spPr>
+          <a:xfrm>
+            <a:off x="9500616" y="1637160"/>
+            <a:ext cx="1792224" cy="274320"/>
+          </a:xfrm>
+          <a:prstGeom prst="rect">
+            <a:avLst/>
+          </a:prstGeom>
+          <a:noFill/>
+        </p:spPr>
+        <p:txBody>
+          <a:bodyPr wrap="square" lIns="0" rIns="0" tIns="0" bIns="0">
+            <a:spAutoFit/>
+          </a:bodyPr>
+          <a:lstStyle/>
+          <a:p>
+            <a:pPr algn="l"/>
+            <a:r>
+              <a:rPr sz="1600" b="1">
+                <a:solidFill>
+                  <a:srgbClr val="7C5CFC"/>
+                </a:solidFill>
+                <a:latin typeface="Calibri"/>
+              </a:rPr>
+              <a:t>5</a:t>
+            </a:r>
+          </a:p>
+        </p:txBody>
+      </p:sp>
+      <p:sp>
+        <p:nvSpPr>
+          <p:cNvPr id="26" name="TextBox 25"/>
+          <p:cNvSpPr txBox="1"/>
+          <p:nvPr/>
+        </p:nvSpPr>
+        <p:spPr>
+          <a:xfrm>
+            <a:off x="9500616" y="1911480"/>
+            <a:ext cx="1792224" cy="411480"/>
+          </a:xfrm>
+          <a:prstGeom prst="rect">
+            <a:avLst/>
+          </a:prstGeom>
+          <a:noFill/>
+        </p:spPr>
+        <p:txBody>
+          <a:bodyPr wrap="square" lIns="0" rIns="0" tIns="0" bIns="0">
+            <a:spAutoFit/>
+          </a:bodyPr>
+          <a:lstStyle/>
+          <a:p>
+            <a:pPr algn="l"/>
+            <a:r>
+              <a:rPr sz="1150" b="1">
+                <a:solidFill>
+                  <a:srgbClr val="FFFFFF"/>
+                </a:solidFill>
+                <a:latin typeface="Calibri"/>
+              </a:rPr>
+              <a:t>Livrable + audit</a:t>
+            </a:r>
+          </a:p>
+        </p:txBody>
+      </p:sp>
+      <p:sp>
+        <p:nvSpPr>
+          <p:cNvPr id="27" name="TextBox 26"/>
+          <p:cNvSpPr txBox="1"/>
+          <p:nvPr/>
+        </p:nvSpPr>
+        <p:spPr>
+          <a:xfrm>
+            <a:off x="9500616" y="2300100"/>
+            <a:ext cx="1792224" cy="411480"/>
+          </a:xfrm>
+          <a:prstGeom prst="rect">
+            <a:avLst/>
+          </a:prstGeom>
+          <a:noFill/>
+        </p:spPr>
+        <p:txBody>
+          <a:bodyPr wrap="square" lIns="0" rIns="0" tIns="0" bIns="0">
+            <a:spAutoFit/>
+          </a:bodyPr>
+          <a:lstStyle/>
+          <a:p>
+            <a:pPr algn="l"/>
+            <a:r>
+              <a:rPr sz="950" b="0">
+                <a:solidFill>
+                  <a:srgbClr val="B7C0D8"/>
+                </a:solidFill>
+                <a:latin typeface="Calibri"/>
+              </a:rPr>
+              <a:t>Archive Drive + journal Supabase</a:t>
+            </a:r>
+          </a:p>
+        </p:txBody>
+      </p:sp>
+      <p:sp>
+        <p:nvSpPr>
+          <p:cNvPr id="28" name="TextBox 27"/>
+          <p:cNvSpPr txBox="1"/>
+          <p:nvPr/>
+        </p:nvSpPr>
+        <p:spPr>
+          <a:xfrm>
+            <a:off x="548640" y="2960000"/>
+            <a:ext cx="7315200" cy="320040"/>
+          </a:xfrm>
+          <a:prstGeom prst="rect">
+            <a:avLst/>
+          </a:prstGeom>
+          <a:noFill/>
+        </p:spPr>
+        <p:txBody>
+          <a:bodyPr wrap="square" lIns="0" rIns="0" tIns="0" bIns="0">
+            <a:spAutoFit/>
+          </a:bodyPr>
+          <a:lstStyle/>
+          <a:p>
+            <a:pPr algn="l"/>
+            <a:r>
+              <a:rPr sz="1500" b="1">
+                <a:solidFill>
+                  <a:srgbClr val="FFFFFF"/>
+                </a:solidFill>
+                <a:latin typeface="Calibri"/>
+              </a:rPr>
+              <a:t>Exemple réel (rejoué avec le code de production)</a:t>
+            </a:r>
+          </a:p>
+        </p:txBody>
+      </p:sp>
+      <p:sp>
+        <p:nvSpPr>
+          <p:cNvPr id="29" name="Rounded Rectangle 28"/>
+          <p:cNvSpPr/>
+          <p:nvPr/>
+        </p:nvSpPr>
+        <p:spPr>
+          <a:xfrm>
+            <a:off x="548640" y="3330000"/>
+            <a:ext cx="5257800" cy="1650000"/>
+          </a:xfrm>
+          <a:prstGeom prst="roundRect">
+            <a:avLst>
+              <a:gd name="adj" fmla="val 6000"/>
+            </a:avLst>
+          </a:prstGeom>
+          <a:solidFill>
+            <a:srgbClr val="16304F"/>
+          </a:solidFill>
+          <a:ln>
+            <a:noFill/>
+          </a:ln>
+          <a:effectLst/>
+        </p:spPr>
+        <p:style>
+          <a:lnRef idx="1">
+            <a:schemeClr val="accent1"/>
+          </a:lnRef>
+          <a:fillRef idx="3">
+            <a:schemeClr val="accent1"/>
+          </a:fillRef>
+          <a:effectRef idx="2">
+            <a:schemeClr val="accent1"/>
+          </a:effectRef>
+          <a:fontRef idx="minor">
+            <a:schemeClr val="lt1"/>
+          </a:fontRef>
+        </p:style>
+        <p:txBody>
+          <a:bodyPr rtlCol="0" anchor="ctr"/>
+          <a:lstStyle/>
+          <a:p>
+            <a:pPr algn="ctr"/>
+          </a:p>
+        </p:txBody>
+      </p:sp>
+      <p:sp>
+        <p:nvSpPr>
+          <p:cNvPr id="30" name="TextBox 29"/>
+          <p:cNvSpPr txBox="1"/>
+          <p:nvPr/>
+        </p:nvSpPr>
+        <p:spPr>
+          <a:xfrm>
+            <a:off x="822960" y="3494592"/>
+            <a:ext cx="4709160" cy="274320"/>
+          </a:xfrm>
+          <a:prstGeom prst="rect">
+            <a:avLst/>
+          </a:prstGeom>
+          <a:noFill/>
+        </p:spPr>
+        <p:txBody>
+          <a:bodyPr wrap="square" lIns="0" rIns="0" tIns="0" bIns="0">
+            <a:spAutoFit/>
+          </a:bodyPr>
+          <a:lstStyle/>
+          <a:p>
+            <a:pPr algn="l"/>
+            <a:r>
+              <a:rPr sz="1100" b="1">
+                <a:solidFill>
+                  <a:srgbClr val="7C5CFC"/>
+                </a:solidFill>
+                <a:latin typeface="Calibri"/>
+              </a:rPr>
+              <a:t>AVANT (jamais transmis à l'IA)</a:t>
+            </a:r>
+          </a:p>
+        </p:txBody>
+      </p:sp>
+      <p:sp>
+        <p:nvSpPr>
+          <p:cNvPr id="31" name="TextBox 30"/>
+          <p:cNvSpPr txBox="1"/>
+          <p:nvPr/>
+        </p:nvSpPr>
+        <p:spPr>
+          <a:xfrm>
+            <a:off x="822960" y="3805488"/>
+            <a:ext cx="4709160" cy="1009920"/>
+          </a:xfrm>
+          <a:prstGeom prst="rect">
+            <a:avLst/>
+          </a:prstGeom>
+          <a:noFill/>
+        </p:spPr>
+        <p:txBody>
+          <a:bodyPr wrap="square" lIns="0" rIns="0" tIns="0" bIns="0">
+            <a:spAutoFit/>
+          </a:bodyPr>
+          <a:lstStyle/>
+          <a:p>
+            <a:pPr algn="l"/>
+            <a:r>
+              <a:rPr sz="1100" b="0">
+                <a:solidFill>
+                  <a:srgbClr val="B7C0D8"/>
+                </a:solidFill>
+                <a:latin typeface="Calibri"/>
+              </a:rPr>
+              <a:t>Monsieur Traoré a confirmé que le virement de 45 000 000 FCFA transitera par le compte IBAN CI93CI0080012345678901234567. Madame Ouédraogo, en charge du dossier, est joignable à o.ouedraogo@ministere-ci.example ou au +225 07 12 34 56 78. Référence contrat CTR20260892.</a:t>
+            </a:r>
+          </a:p>
+        </p:txBody>
+      </p:sp>
+      <p:sp>
+        <p:nvSpPr>
+          <p:cNvPr id="32" name="Rounded Rectangle 31"/>
+          <p:cNvSpPr/>
+          <p:nvPr/>
+        </p:nvSpPr>
+        <p:spPr>
+          <a:xfrm>
+            <a:off x="6080760" y="3330000"/>
+            <a:ext cx="5257800" cy="1650000"/>
+          </a:xfrm>
+          <a:prstGeom prst="roundRect">
+            <a:avLst>
+              <a:gd name="adj" fmla="val 6000"/>
+            </a:avLst>
+          </a:prstGeom>
+          <a:solidFill>
+            <a:srgbClr val="1E1B3D"/>
+          </a:solidFill>
+          <a:ln>
+            <a:noFill/>
+          </a:ln>
+          <a:effectLst/>
+        </p:spPr>
+        <p:style>
+          <a:lnRef idx="1">
+            <a:schemeClr val="accent1"/>
+          </a:lnRef>
+          <a:fillRef idx="3">
+            <a:schemeClr val="accent1"/>
+          </a:fillRef>
+          <a:effectRef idx="2">
+            <a:schemeClr val="accent1"/>
+          </a:effectRef>
+          <a:fontRef idx="minor">
+            <a:schemeClr val="lt1"/>
+          </a:fontRef>
+        </p:style>
+        <p:txBody>
+          <a:bodyPr rtlCol="0" anchor="ctr"/>
+          <a:lstStyle/>
+          <a:p>
+            <a:pPr algn="ctr"/>
+          </a:p>
+        </p:txBody>
+      </p:sp>
+      <p:sp>
+        <p:nvSpPr>
+          <p:cNvPr id="33" name="TextBox 32"/>
+          <p:cNvSpPr txBox="1"/>
+          <p:nvPr/>
+        </p:nvSpPr>
+        <p:spPr>
+          <a:xfrm>
+            <a:off x="6355080" y="3494592"/>
+            <a:ext cx="4709160" cy="274320"/>
+          </a:xfrm>
+          <a:prstGeom prst="rect">
+            <a:avLst/>
+          </a:prstGeom>
+          <a:noFill/>
+        </p:spPr>
+        <p:txBody>
+          <a:bodyPr wrap="square" lIns="0" rIns="0" tIns="0" bIns="0">
+            <a:spAutoFit/>
+          </a:bodyPr>
+          <a:lstStyle/>
+          <a:p>
+            <a:pPr algn="l"/>
+            <a:r>
+              <a:rPr sz="1100" b="1">
+                <a:solidFill>
+                  <a:srgbClr val="7C5CFC"/>
+                </a:solidFill>
+                <a:latin typeface="Calibri"/>
+              </a:rPr>
+              <a:t>APRÈS (ce que voit OpenAI)</a:t>
+            </a:r>
+          </a:p>
+        </p:txBody>
+      </p:sp>
+      <p:sp>
+        <p:nvSpPr>
+          <p:cNvPr id="34" name="TextBox 33"/>
+          <p:cNvSpPr txBox="1"/>
+          <p:nvPr/>
+        </p:nvSpPr>
+        <p:spPr>
+          <a:xfrm>
+            <a:off x="6355080" y="3805488"/>
+            <a:ext cx="4709160" cy="1009920"/>
+          </a:xfrm>
+          <a:prstGeom prst="rect">
+            <a:avLst/>
+          </a:prstGeom>
+          <a:noFill/>
+        </p:spPr>
+        <p:txBody>
+          <a:bodyPr wrap="square" lIns="0" rIns="0" tIns="0" bIns="0">
+            <a:spAutoFit/>
+          </a:bodyPr>
+          <a:lstStyle/>
+          <a:p>
+            <a:pPr algn="l"/>
+            <a:r>
+              <a:rPr sz="1100" b="0">
+                <a:solidFill>
+                  <a:srgbClr val="EDE9FF"/>
+                </a:solidFill>
+                <a:latin typeface="Calibri"/>
+              </a:rPr>
+              <a:t>Monsieur PARTY_003 a confirmé que le virement de AMOUNT_001 transitera par le compte IBAN IBAN_001. Madame PARTY_002, en charge du dossier, est joignable à EMAIL_001 ou au PHONE_001. Référence contrat ID_001.</a:t>
+            </a:r>
+          </a:p>
+        </p:txBody>
+      </p:sp>
+      <p:sp>
+        <p:nvSpPr>
+          <p:cNvPr id="35" name="Rounded Rectangle 34"/>
+          <p:cNvSpPr/>
+          <p:nvPr/>
+        </p:nvSpPr>
+        <p:spPr>
+          <a:xfrm>
+            <a:off x="548640" y="5117160"/>
+            <a:ext cx="10881360" cy="1140000"/>
+          </a:xfrm>
+          <a:prstGeom prst="roundRect">
+            <a:avLst>
+              <a:gd name="adj" fmla="val 6000"/>
+            </a:avLst>
+          </a:prstGeom>
+          <a:solidFill>
+            <a:srgbClr val="16304F"/>
+          </a:solidFill>
+          <a:ln>
+            <a:noFill/>
+          </a:ln>
+          <a:effectLst/>
+        </p:spPr>
+        <p:style>
+          <a:lnRef idx="1">
+            <a:schemeClr val="accent1"/>
+          </a:lnRef>
+          <a:fillRef idx="3">
+            <a:schemeClr val="accent1"/>
+          </a:fillRef>
+          <a:effectRef idx="2">
+            <a:schemeClr val="accent1"/>
+          </a:effectRef>
+          <a:fontRef idx="minor">
+            <a:schemeClr val="lt1"/>
+          </a:fontRef>
+        </p:style>
+        <p:txBody>
+          <a:bodyPr rtlCol="0" anchor="ctr"/>
+          <a:lstStyle/>
+          <a:p>
+            <a:pPr algn="ctr"/>
+          </a:p>
+        </p:txBody>
+      </p:sp>
+      <p:sp>
+        <p:nvSpPr>
+          <p:cNvPr id="36" name="TextBox 35"/>
+          <p:cNvSpPr txBox="1"/>
+          <p:nvPr/>
+        </p:nvSpPr>
+        <p:spPr>
+          <a:xfrm>
+            <a:off x="822960" y="5254320"/>
+            <a:ext cx="10333440" cy="640080"/>
+          </a:xfrm>
+          <a:prstGeom prst="rect">
+            <a:avLst/>
+          </a:prstGeom>
+          <a:noFill/>
+        </p:spPr>
+        <p:txBody>
+          <a:bodyPr wrap="square" lIns="0" rIns="0" tIns="0" bIns="0">
+            <a:spAutoFit/>
+          </a:bodyPr>
+          <a:lstStyle/>
+          <a:p>
+            <a:r>
+              <a:rPr sz="1300" b="1">
+                <a:solidFill>
+                  <a:srgbClr val="7C5CFC"/>
+                </a:solidFill>
+                <a:latin typeface="Calibri"/>
+              </a:rPr>
+              <a:t>Bénéfices pour la diplomatie : </a:t>
+            </a:r>
+            <a:r>
+              <a:rPr sz="1300">
+                <a:solidFill>
+                  <a:srgbClr val="FFFFFF"/>
+                </a:solidFill>
+                <a:latin typeface="Calibri"/>
+              </a:rPr>
+              <a:t>un compte rendu multilingue (FR/EN/ESP) prêt à diffuser après une réunion bilatérale ou multilatérale, sans qu'un nom, un poste ou un détail cité en séance ne quitte jamais le pays vers un service IA externe.</a:t>
+            </a:r>
+          </a:p>
+        </p:txBody>
+      </p:sp>
+      <p:sp>
+        <p:nvSpPr>
+          <p:cNvPr id="37" name="TextBox 36"/>
+          <p:cNvSpPr txBox="1"/>
+          <p:nvPr/>
+        </p:nvSpPr>
+        <p:spPr>
+          <a:xfrm>
+            <a:off x="822960" y="5917260"/>
+            <a:ext cx="10333440" cy="274320"/>
+          </a:xfrm>
+          <a:prstGeom prst="rect">
+            <a:avLst/>
+          </a:prstGeom>
+          <a:noFill/>
+        </p:spPr>
+        <p:txBody>
+          <a:bodyPr wrap="square" lIns="0" rIns="0" tIns="0" bIns="0">
+            <a:spAutoFit/>
+          </a:bodyPr>
+          <a:lstStyle/>
+          <a:p>
+            <a:pPr algn="l"/>
+            <a:r>
+              <a:rPr sz="1050" b="0">
+                <a:solidFill>
+                  <a:srgbClr val="8A93AC"/>
+                </a:solidFill>
+                <a:latin typeface="Calibri"/>
+              </a:rPr>
+              <a:t>Retour sur investissement estimé : moins de temps de rédaction post-réunion pour l'assistant(e) de direction — ordre de grandeur indicatif, à valider selon le rythme de réunions de la mission.</a:t>
+            </a:r>
+          </a:p>
+        </p:txBody>
+      </p:sp>
+      <p:sp>
+        <p:nvSpPr>
+          <p:cNvPr id="38" name="TextBox 37"/>
+          <p:cNvSpPr txBox="1"/>
+          <p:nvPr/>
+        </p:nvSpPr>
+        <p:spPr>
+          <a:xfrm>
+            <a:off x="457200" y="6473952"/>
+            <a:ext cx="7315200" cy="274320"/>
+          </a:xfrm>
+          <a:prstGeom prst="rect">
+            <a:avLst/>
+          </a:prstGeom>
+          <a:noFill/>
+        </p:spPr>
+        <p:txBody>
+          <a:bodyPr wrap="square" lIns="0" rIns="0" tIns="0" bIns="0">
+            <a:spAutoFit/>
+          </a:bodyPr>
+          <a:lstStyle/>
+          <a:p>
+            <a:pPr algn="l"/>
+            <a:r>
+              <a:rPr sz="900" b="0">
+                <a:solidFill>
+                  <a:srgbClr val="8A93AC"/>
+                </a:solidFill>
+                <a:latin typeface="Calibri"/>
+              </a:rPr>
+              <a:t>TransferAI Africa  •  Compte Rendu de Réunion Internationale</a:t>
+            </a:r>
+          </a:p>
+        </p:txBody>
+      </p:sp>
+      <p:sp>
+        <p:nvSpPr>
+          <p:cNvPr id="39" name="TextBox 38"/>
+          <p:cNvSpPr txBox="1"/>
+          <p:nvPr/>
+        </p:nvSpPr>
+        <p:spPr>
+          <a:xfrm>
+            <a:off x="8503920" y="6473952"/>
+            <a:ext cx="3200400" cy="274320"/>
+          </a:xfrm>
+          <a:prstGeom prst="rect">
+            <a:avLst/>
+          </a:prstGeom>
+          <a:noFill/>
+        </p:spPr>
+        <p:txBody>
+          <a:bodyPr wrap="square" lIns="0" rIns="0" tIns="0" bIns="0">
+            <a:spAutoFit/>
+          </a:bodyPr>
+          <a:lstStyle/>
+          <a:p>
+            <a:pPr algn="l"/>
+            <a:r>
+              <a:rPr sz="900" b="0">
+                <a:solidFill>
+                  <a:srgbClr val="8A93AC"/>
+                </a:solidFill>
+                <a:latin typeface="Calibri"/>
+              </a:rPr>
+              <a:t>18 juillet 2026</a:t>
+            </a:r>
           </a:p>
         </p:txBody>
       </p:sp>
@@ -3076,319 +5360,4 @@
     </a:ext>
   </a:extLst>
 </a:theme>
-</file>
-
-<file path=ppt/theme/theme2.xml><?xml version="1.0" encoding="utf-8"?>
-<a:theme xmlns:a="http://schemas.openxmlformats.org/drawingml/2006/main" name="Office Theme">
-  <a:themeElements>
-    <a:clrScheme name="Office">
-      <a:dk1>
-        <a:sysClr val="windowText" lastClr="000000"/>
-      </a:dk1>
-      <a:lt1>
-        <a:sysClr val="window" lastClr="FFFFFF"/>
-      </a:lt1>
-      <a:dk2>
-        <a:srgbClr val="0E2841"/>
-      </a:dk2>
-      <a:lt2>
-        <a:srgbClr val="E8E8E8"/>
-      </a:lt2>
-      <a:accent1>
-        <a:srgbClr val="156082"/>
-      </a:accent1>
-      <a:accent2>
-        <a:srgbClr val="E97132"/>
-      </a:accent2>
-      <a:accent3>
-        <a:srgbClr val="196B24"/>
-      </a:accent3>
-      <a:accent4>
-        <a:srgbClr val="0F9ED5"/>
-      </a:accent4>
-      <a:accent5>
-        <a:srgbClr val="A02B93"/>
-      </a:accent5>
-      <a:accent6>
-        <a:srgbClr val="4EA72E"/>
-      </a:accent6>
-      <a:hlink>
-        <a:srgbClr val="467886"/>
-      </a:hlink>
-      <a:folHlink>
-        <a:srgbClr val="96607D"/>
-      </a:folHlink>
-    </a:clrScheme>
-    <a:fontScheme name="Office">
-      <a:majorFont>
-        <a:latin typeface="Aptos Display" panose="02110004020202020204"/>
-        <a:ea typeface=""/>
-        <a:cs typeface=""/>
-        <a:font script="Jpan" typeface="游ゴシック Light"/>
-        <a:font script="Hang" typeface="맑은 고딕"/>
-        <a:font script="Hans" typeface="等线 Light"/>
-        <a:font script="Hant" typeface="新細明體"/>
-        <a:font script="Arab" typeface="Times New Roman"/>
-        <a:font script="Hebr" typeface="Times New Roman"/>
-        <a:font script="Thai" typeface="Angsana New"/>
-        <a:font script="Ethi" typeface="Nyala"/>
-        <a:font script="Beng" typeface="Vrinda"/>
-        <a:font script="Gujr" typeface="Shruti"/>
-        <a:font script="Khmr" typeface="MoolBoran"/>
-        <a:font script="Knda" typeface="Tunga"/>
-        <a:font script="Guru" typeface="Raavi"/>
-        <a:font script="Cans" typeface="Euphemia"/>
-        <a:font script="Cher" typeface="Plantagenet Cherokee"/>
-        <a:font script="Yiii" typeface="Microsoft Yi Baiti"/>
-        <a:font script="Tibt" typeface="Microsoft Himalaya"/>
-        <a:font script="Thaa" typeface="MV Boli"/>
-        <a:font script="Deva" typeface="Mangal"/>
-        <a:font script="Telu" typeface="Gautami"/>
-        <a:font script="Taml" typeface="Latha"/>
-        <a:font script="Syrc" typeface="Estrangelo Edessa"/>
-        <a:font script="Orya" typeface="Kalinga"/>
-        <a:font script="Mlym" typeface="Kartika"/>
-        <a:font script="Laoo" typeface="DokChampa"/>
-        <a:font script="Sinh" typeface="Iskoola Pota"/>
-        <a:font script="Mong" typeface="Mongolian Baiti"/>
-        <a:font script="Viet" typeface="Times New Roman"/>
-        <a:font script="Uigh" typeface="Microsoft Uighur"/>
-        <a:font script="Geor" typeface="Sylfaen"/>
-        <a:font script="Armn" typeface="Arial"/>
-        <a:font script="Bugi" typeface="Leelawadee UI"/>
-        <a:font script="Bopo" typeface="Microsoft JhengHei"/>
-        <a:font script="Java" typeface="Javanese Text"/>
-        <a:font script="Lisu" typeface="Segoe UI"/>
-        <a:font script="Mymr" typeface="Myanmar Text"/>
-        <a:font script="Nkoo" typeface="Ebrima"/>
-        <a:font script="Olck" typeface="Nirmala UI"/>
-        <a:font script="Osma" typeface="Ebrima"/>
-        <a:font script="Phag" typeface="Phagspa"/>
-        <a:font script="Syrn" typeface="Estrangelo Edessa"/>
-        <a:font script="Syrj" typeface="Estrangelo Edessa"/>
-        <a:font script="Syre" typeface="Estrangelo Edessa"/>
-        <a:font script="Sora" typeface="Nirmala UI"/>
-        <a:font script="Tale" typeface="Microsoft Tai Le"/>
-        <a:font script="Talu" typeface="Microsoft New Tai Lue"/>
-        <a:font script="Tfng" typeface="Ebrima"/>
-      </a:majorFont>
-      <a:minorFont>
-        <a:latin typeface="Aptos" panose="02110004020202020204"/>
-        <a:ea typeface=""/>
-        <a:cs typeface=""/>
-        <a:font script="Jpan" typeface="游ゴシック"/>
-        <a:font script="Hang" typeface="맑은 고딕"/>
-        <a:font script="Hans" typeface="等线"/>
-        <a:font script="Hant" typeface="新細明體"/>
-        <a:font script="Arab" typeface="Arial"/>
-        <a:font script="Hebr" typeface="Arial"/>
-        <a:font script="Thai" typeface="Cordia New"/>
-        <a:font script="Ethi" typeface="Nyala"/>
-        <a:font script="Beng" typeface="Vrinda"/>
-        <a:font script="Gujr" typeface="Shruti"/>
-        <a:font script="Khmr" typeface="DaunPenh"/>
-        <a:font script="Knda" typeface="Tunga"/>
-        <a:font script="Guru" typeface="Raavi"/>
-        <a:font script="Cans" typeface="Euphemia"/>
-        <a:font script="Cher" typeface="Plantagenet Cherokee"/>
-        <a:font script="Yiii" typeface="Microsoft Yi Baiti"/>
-        <a:font script="Tibt" typeface="Microsoft Himalaya"/>
-        <a:font script="Thaa" typeface="MV Boli"/>
-        <a:font script="Deva" typeface="Mangal"/>
-        <a:font script="Telu" typeface="Gautami"/>
-        <a:font script="Taml" typeface="Latha"/>
-        <a:font script="Syrc" typeface="Estrangelo Edessa"/>
-        <a:font script="Orya" typeface="Kalinga"/>
-        <a:font script="Mlym" typeface="Kartika"/>
-        <a:font script="Laoo" typeface="DokChampa"/>
-        <a:font script="Sinh" typeface="Iskoola Pota"/>
-        <a:font script="Mong" typeface="Mongolian Baiti"/>
-        <a:font script="Viet" typeface="Arial"/>
-        <a:font script="Uigh" typeface="Microsoft Uighur"/>
-        <a:font script="Geor" typeface="Sylfaen"/>
-        <a:font script="Armn" typeface="Arial"/>
-        <a:font script="Bugi" typeface="Leelawadee UI"/>
-        <a:font script="Bopo" typeface="Microsoft JhengHei"/>
-        <a:font script="Java" typeface="Javanese Text"/>
-        <a:font script="Lisu" typeface="Segoe UI"/>
-        <a:font script="Mymr" typeface="Myanmar Text"/>
-        <a:font script="Nkoo" typeface="Ebrima"/>
-        <a:font script="Olck" typeface="Nirmala UI"/>
-        <a:font script="Osma" typeface="Ebrima"/>
-        <a:font script="Phag" typeface="Phagspa"/>
-        <a:font script="Syrn" typeface="Estrangelo Edessa"/>
-        <a:font script="Syrj" typeface="Estrangelo Edessa"/>
-        <a:font script="Syre" typeface="Estrangelo Edessa"/>
-        <a:font script="Sora" typeface="Nirmala UI"/>
-        <a:font script="Tale" typeface="Microsoft Tai Le"/>
-        <a:font script="Talu" typeface="Microsoft New Tai Lue"/>
-        <a:font script="Tfng" typeface="Ebrima"/>
-      </a:minorFont>
-    </a:fontScheme>
-    <a:fmtScheme name="Office">
-      <a:fillStyleLst>
-        <a:solidFill>
-          <a:schemeClr val="phClr"/>
-        </a:solidFill>
-        <a:gradFill rotWithShape="1">
-          <a:gsLst>
-            <a:gs pos="0">
-              <a:schemeClr val="phClr">
-                <a:lumMod val="110000"/>
-                <a:satMod val="105000"/>
-                <a:tint val="67000"/>
-              </a:schemeClr>
-            </a:gs>
-            <a:gs pos="50000">
-              <a:schemeClr val="phClr">
-                <a:lumMod val="105000"/>
-                <a:satMod val="103000"/>
-                <a:tint val="73000"/>
-              </a:schemeClr>
-            </a:gs>
-            <a:gs pos="100000">
-              <a:schemeClr val="phClr">
-                <a:lumMod val="105000"/>
-                <a:satMod val="109000"/>
-                <a:tint val="81000"/>
-              </a:schemeClr>
-            </a:gs>
-          </a:gsLst>
-          <a:lin ang="5400000" scaled="0"/>
-        </a:gradFill>
-        <a:gradFill rotWithShape="1">
-          <a:gsLst>
-            <a:gs pos="0">
-              <a:schemeClr val="phClr">
-                <a:satMod val="103000"/>
-                <a:lumMod val="102000"/>
-                <a:tint val="94000"/>
-              </a:schemeClr>
-            </a:gs>
-            <a:gs pos="50000">
-              <a:schemeClr val="phClr">
-                <a:satMod val="110000"/>
-                <a:lumMod val="100000"/>
-                <a:shade val="100000"/>
-              </a:schemeClr>
-            </a:gs>
-            <a:gs pos="100000">
-              <a:schemeClr val="phClr">
-                <a:lumMod val="99000"/>
-                <a:satMod val="120000"/>
-                <a:shade val="78000"/>
-              </a:schemeClr>
-            </a:gs>
-          </a:gsLst>
-          <a:lin ang="5400000" scaled="0"/>
-        </a:gradFill>
-      </a:fillStyleLst>
-      <a:lnStyleLst>
-        <a:ln w="12700" cap="flat" cmpd="sng" algn="ctr">
-          <a:solidFill>
-            <a:schemeClr val="phClr"/>
-          </a:solidFill>
-          <a:prstDash val="solid"/>
-          <a:miter lim="800000"/>
-        </a:ln>
-        <a:ln w="19050" cap="flat" cmpd="sng" algn="ctr">
-          <a:solidFill>
-            <a:schemeClr val="phClr"/>
-          </a:solidFill>
-          <a:prstDash val="solid"/>
-          <a:miter lim="800000"/>
-        </a:ln>
-        <a:ln w="25400" cap="flat" cmpd="sng" algn="ctr">
-          <a:solidFill>
-            <a:schemeClr val="phClr"/>
-          </a:solidFill>
-          <a:prstDash val="solid"/>
-          <a:miter lim="800000"/>
-        </a:ln>
-      </a:lnStyleLst>
-      <a:effectStyleLst>
-        <a:effectStyle>
-          <a:effectLst/>
-        </a:effectStyle>
-        <a:effectStyle>
-          <a:effectLst/>
-        </a:effectStyle>
-        <a:effectStyle>
-          <a:effectLst>
-            <a:outerShdw blurRad="57150" dist="19050" dir="5400000" algn="ctr" rotWithShape="0">
-              <a:srgbClr val="000000">
-                <a:alpha val="63000"/>
-              </a:srgbClr>
-            </a:outerShdw>
-          </a:effectLst>
-        </a:effectStyle>
-      </a:effectStyleLst>
-      <a:bgFillStyleLst>
-        <a:solidFill>
-          <a:schemeClr val="phClr"/>
-        </a:solidFill>
-        <a:solidFill>
-          <a:schemeClr val="phClr">
-            <a:tint val="95000"/>
-            <a:satMod val="170000"/>
-          </a:schemeClr>
-        </a:solidFill>
-        <a:gradFill rotWithShape="1">
-          <a:gsLst>
-            <a:gs pos="0">
-              <a:schemeClr val="phClr">
-                <a:tint val="93000"/>
-                <a:satMod val="150000"/>
-                <a:shade val="98000"/>
-                <a:lumMod val="102000"/>
-              </a:schemeClr>
-            </a:gs>
-            <a:gs pos="50000">
-              <a:schemeClr val="phClr">
-                <a:tint val="98000"/>
-                <a:satMod val="130000"/>
-                <a:shade val="90000"/>
-                <a:lumMod val="103000"/>
-              </a:schemeClr>
-            </a:gs>
-            <a:gs pos="100000">
-              <a:schemeClr val="phClr">
-                <a:shade val="63000"/>
-                <a:satMod val="120000"/>
-              </a:schemeClr>
-            </a:gs>
-          </a:gsLst>
-          <a:lin ang="5400000" scaled="0"/>
-        </a:gradFill>
-      </a:bgFillStyleLst>
-    </a:fmtScheme>
-  </a:themeElements>
-  <a:objectDefaults>
-    <a:lnDef>
-      <a:spPr/>
-      <a:bodyPr/>
-      <a:lstStyle/>
-      <a:style>
-        <a:lnRef idx="2">
-          <a:schemeClr val="accent1"/>
-        </a:lnRef>
-        <a:fillRef idx="0">
-          <a:schemeClr val="accent1"/>
-        </a:fillRef>
-        <a:effectRef idx="1">
-          <a:schemeClr val="accent1"/>
-        </a:effectRef>
-        <a:fontRef idx="minor">
-          <a:schemeClr val="tx1"/>
-        </a:fontRef>
-      </a:style>
-    </a:lnDef>
-  </a:objectDefaults>
-  <a:extraClrSchemeLst/>
-  <a:extLst>
-    <a:ext uri="{05A4C25C-085E-4340-85A3-A5531E510DB2}">
-      <thm15:themeFamily xmlns:thm15="http://schemas.microsoft.com/office/thememl/2012/main" name="Office Theme" id="{2E142A2C-CD16-42D6-873A-C26D2A0506FA}" vid="{1BDDFF52-6CD6-40A5-AB3C-68EB2F1E4D0A}"/>
-    </a:ext>
-  </a:extLst>
-</a:theme>
 </file>
</xml_diff>